<commit_message>
Ground recovery motivation in incidents and deepen technical comparisons
</commit_message>
<xml_diff>
--- a/slides/trust4rsi-paper-deck/trust4rsi-technical-appendix.pptx
+++ b/slides/trust4rsi-paper-deck/trust4rsi-technical-appendix.pptx
@@ -25,6 +25,10 @@
     <p:sldId id="284" r:id="rId35"/>
     <p:sldId id="285" r:id="rId36"/>
     <p:sldId id="286" r:id="rId37"/>
+    <p:sldId id="287" r:id="rId38"/>
+    <p:sldId id="288" r:id="rId39"/>
+    <p:sldId id="289" r:id="rId40"/>
+    <p:sldId id="290" r:id="rId41"/>
   </p:sldIdLst>
   <p:sldSz cx="12191695" cy="6858000" type="screen4x3"/>
   <p:notesSz cx="6858000" cy="9144000"/>
@@ -16963,7 +16967,7 @@
                           </a:solidFill>
                           <a:latin typeface="Arial"/>
                         </a:rPr>
-                        <a:t>Separate environments; missing packages, message caps and unknowns</a:t>
+                        <a:t>Baseline: report-only; raw live archive absent. Preflight retains unknowns</a:t>
                       </a:r>
                     </a:p>
                   </a:txBody>
@@ -17709,7 +17713,7 @@
                 </a:solidFill>
                 <a:latin typeface="Arial"/>
               </a:rPr>
-              <a:t>Every result shown comes from a recorded API response and/or the local service effects of an actor call</a:t>
+              <a:t>The local service results below come from recorded API responses and service effects</a:t>
             </a:r>
           </a:p>
         </p:txBody>
@@ -20754,6 +20758,3290 @@
           </a:p>
         </p:txBody>
       </p:sp>
+      <p:sp>
+        <p:nvSpPr>
+          <p:cNvPr id="16" name="TextBox 15"/>
+          <p:cNvSpPr txBox="1"/>
+          <p:nvPr/>
+        </p:nvSpPr>
+        <p:spPr>
+          <a:xfrm>
+            <a:off x="457200" y="4974336"/>
+            <a:ext cx="11277295" cy="393192"/>
+          </a:xfrm>
+          <a:prstGeom prst="rect">
+            <a:avLst/>
+          </a:prstGeom>
+          <a:noFill/>
+        </p:spPr>
+        <p:txBody>
+          <a:bodyPr wrap="square" lIns="45720" rIns="45720" tIns="27432" bIns="27432" anchor="t">
+            <a:spAutoFit/>
+          </a:bodyPr>
+          <a:lstStyle/>
+          <a:p>
+            <a:pPr algn="l">
+              <a:lnSpc>
+                <a:spcPct val="110000"/>
+              </a:lnSpc>
+            </a:pPr>
+            <a:r>
+              <a:rPr sz="1700" b="1" i="0">
+                <a:solidFill>
+                  <a:srgbClr val="111111"/>
+                </a:solidFill>
+                <a:latin typeface="Arial"/>
+              </a:rPr>
+              <a:t>[10] Anthropic — Incident alignment assessment (September 2026)</a:t>
+            </a:r>
+          </a:p>
+        </p:txBody>
+      </p:sp>
+      <p:sp>
+        <p:nvSpPr>
+          <p:cNvPr id="17" name="TextBox 16"/>
+          <p:cNvSpPr txBox="1"/>
+          <p:nvPr/>
+        </p:nvSpPr>
+        <p:spPr>
+          <a:xfrm>
+            <a:off x="457200" y="5385816"/>
+            <a:ext cx="11277295" cy="274320"/>
+          </a:xfrm>
+          <a:prstGeom prst="rect">
+            <a:avLst/>
+          </a:prstGeom>
+          <a:noFill/>
+        </p:spPr>
+        <p:txBody>
+          <a:bodyPr wrap="square" lIns="45720" rIns="45720" tIns="27432" bIns="27432" anchor="t">
+            <a:spAutoFit/>
+          </a:bodyPr>
+          <a:lstStyle/>
+          <a:p>
+            <a:pPr algn="l">
+              <a:lnSpc>
+                <a:spcPct val="110000"/>
+              </a:lnSpc>
+            </a:pPr>
+            <a:r>
+              <a:rPr sz="1200" b="0" i="0">
+                <a:solidFill>
+                  <a:srgbClr val="365E9E"/>
+                </a:solidFill>
+                <a:latin typeface="Arial"/>
+                <a:hlinkClick r:id="rId6"/>
+              </a:rPr>
+              <a:t>https://www.anthropic.com/research/alignment-assessment-cybersecurity-incidents</a:t>
+            </a:r>
+          </a:p>
+        </p:txBody>
+      </p:sp>
+    </p:spTree>
+  </p:cSld>
+  <p:clrMapOvr>
+    <a:masterClrMapping/>
+  </p:clrMapOvr>
+</p:sld>
+</file>
+
+<file path=ppt/slides/slide32.xml><?xml version="1.0" encoding="utf-8"?>
+<p:sld xmlns:a="http://schemas.openxmlformats.org/drawingml/2006/main" xmlns:p="http://schemas.openxmlformats.org/presentationml/2006/main" xmlns:r="http://schemas.openxmlformats.org/officeDocument/2006/relationships">
+  <p:cSld>
+    <p:spTree>
+      <p:nvGrpSpPr>
+        <p:cNvPr id="1" name=""/>
+        <p:cNvGrpSpPr/>
+        <p:nvPr/>
+      </p:nvGrpSpPr>
+      <p:grpSpPr/>
+      <p:sp>
+        <p:nvSpPr>
+          <p:cNvPr id="2" name="TextBox 1"/>
+          <p:cNvSpPr txBox="1"/>
+          <p:nvPr/>
+        </p:nvSpPr>
+        <p:spPr>
+          <a:xfrm>
+            <a:off x="457200" y="256032"/>
+            <a:ext cx="11277295" cy="548640"/>
+          </a:xfrm>
+          <a:prstGeom prst="rect">
+            <a:avLst/>
+          </a:prstGeom>
+          <a:noFill/>
+        </p:spPr>
+        <p:txBody>
+          <a:bodyPr wrap="square" lIns="45720" rIns="45720" tIns="27432" bIns="27432" anchor="t">
+            <a:spAutoFit/>
+          </a:bodyPr>
+          <a:lstStyle/>
+          <a:p>
+            <a:pPr algn="l">
+              <a:lnSpc>
+                <a:spcPct val="110000"/>
+              </a:lnSpc>
+            </a:pPr>
+            <a:r>
+              <a:rPr sz="2300" b="1" i="0">
+                <a:solidFill>
+                  <a:srgbClr val="111111"/>
+                </a:solidFill>
+                <a:latin typeface="Arial"/>
+              </a:rPr>
+              <a:t>Incident evidence becomes variables, not benchmark outcomes</a:t>
+            </a:r>
+          </a:p>
+        </p:txBody>
+      </p:sp>
+      <p:sp>
+        <p:nvSpPr>
+          <p:cNvPr id="3" name="TextBox 2"/>
+          <p:cNvSpPr txBox="1"/>
+          <p:nvPr/>
+        </p:nvSpPr>
+        <p:spPr>
+          <a:xfrm>
+            <a:off x="457200" y="786384"/>
+            <a:ext cx="11277295" cy="384048"/>
+          </a:xfrm>
+          <a:prstGeom prst="rect">
+            <a:avLst/>
+          </a:prstGeom>
+          <a:noFill/>
+        </p:spPr>
+        <p:txBody>
+          <a:bodyPr wrap="square" lIns="45720" rIns="45720" tIns="27432" bIns="27432" anchor="t">
+            <a:spAutoFit/>
+          </a:bodyPr>
+          <a:lstStyle/>
+          <a:p>
+            <a:pPr algn="l">
+              <a:lnSpc>
+                <a:spcPct val="110000"/>
+              </a:lnSpc>
+            </a:pPr>
+            <a:r>
+              <a:rPr sz="1250" b="0" i="1">
+                <a:solidFill>
+                  <a:srgbClr val="666666"/>
+                </a:solidFill>
+                <a:latin typeface="Arial"/>
+              </a:rPr>
+              <a:t>Reports motivate hypotheses. Our local experiments do not reproduce these production incidents.</a:t>
+            </a:r>
+          </a:p>
+        </p:txBody>
+      </p:sp>
+      <p:sp>
+        <p:nvSpPr>
+          <p:cNvPr id="4" name="Rectangle 3"/>
+          <p:cNvSpPr/>
+          <p:nvPr/>
+        </p:nvSpPr>
+        <p:spPr>
+          <a:xfrm>
+            <a:off x="457200" y="1188720"/>
+            <a:ext cx="11277295" cy="19050"/>
+          </a:xfrm>
+          <a:prstGeom prst="rect">
+            <a:avLst/>
+          </a:prstGeom>
+          <a:solidFill>
+            <a:srgbClr val="365E9E"/>
+          </a:solidFill>
+          <a:ln>
+            <a:noFill/>
+          </a:ln>
+          <a:effectLst/>
+        </p:spPr>
+        <p:style>
+          <a:lnRef idx="1">
+            <a:schemeClr val="accent1"/>
+          </a:lnRef>
+          <a:fillRef idx="3">
+            <a:schemeClr val="accent1"/>
+          </a:fillRef>
+          <a:effectRef idx="2">
+            <a:schemeClr val="accent1"/>
+          </a:effectRef>
+          <a:fontRef idx="minor">
+            <a:schemeClr val="lt1"/>
+          </a:fontRef>
+        </p:style>
+        <p:txBody>
+          <a:bodyPr rtlCol="0" anchor="ctr"/>
+          <a:lstStyle/>
+          <a:p/>
+        </p:txBody>
+      </p:sp>
+      <p:sp>
+        <p:nvSpPr>
+          <p:cNvPr id="5" name="TextBox 4"/>
+          <p:cNvSpPr txBox="1"/>
+          <p:nvPr/>
+        </p:nvSpPr>
+        <p:spPr>
+          <a:xfrm>
+            <a:off x="457200" y="6492240"/>
+            <a:ext cx="10728655" cy="274320"/>
+          </a:xfrm>
+          <a:prstGeom prst="rect">
+            <a:avLst/>
+          </a:prstGeom>
+          <a:noFill/>
+        </p:spPr>
+        <p:txBody>
+          <a:bodyPr wrap="square" lIns="45720" rIns="45720" tIns="27432" bIns="27432" anchor="t">
+            <a:spAutoFit/>
+          </a:bodyPr>
+          <a:lstStyle/>
+          <a:p>
+            <a:pPr algn="l">
+              <a:lnSpc>
+                <a:spcPct val="110000"/>
+              </a:lnSpc>
+            </a:pPr>
+            <a:r>
+              <a:rPr sz="800" b="0" i="0">
+                <a:solidFill>
+                  <a:srgbClr val="666666"/>
+                </a:solidFill>
+                <a:latin typeface="Arial"/>
+              </a:rPr>
+              <a:t>Technical appendix | 20 Oct 2026 | Observed API runs in local services | Detailed methods and primary references.</a:t>
+            </a:r>
+          </a:p>
+        </p:txBody>
+      </p:sp>
+      <p:sp>
+        <p:nvSpPr>
+          <p:cNvPr id="6" name="TextBox 5"/>
+          <p:cNvSpPr txBox="1"/>
+          <p:nvPr/>
+        </p:nvSpPr>
+        <p:spPr>
+          <a:xfrm>
+            <a:off x="11277295" y="6492240"/>
+            <a:ext cx="457200" cy="274320"/>
+          </a:xfrm>
+          <a:prstGeom prst="rect">
+            <a:avLst/>
+          </a:prstGeom>
+          <a:noFill/>
+        </p:spPr>
+        <p:txBody>
+          <a:bodyPr wrap="square" lIns="45720" rIns="45720" tIns="27432" bIns="27432" anchor="t">
+            <a:spAutoFit/>
+          </a:bodyPr>
+          <a:lstStyle/>
+          <a:p>
+            <a:pPr algn="r">
+              <a:lnSpc>
+                <a:spcPct val="110000"/>
+              </a:lnSpc>
+            </a:pPr>
+            <a:r>
+              <a:rPr sz="900" b="0" i="0">
+                <a:solidFill>
+                  <a:srgbClr val="666666"/>
+                </a:solidFill>
+                <a:latin typeface="Arial"/>
+              </a:rPr>
+              <a:t>A21</a:t>
+            </a:r>
+          </a:p>
+        </p:txBody>
+      </p:sp>
+      <p:sp>
+        <p:nvSpPr>
+          <p:cNvPr id="7" name="TextBox 6"/>
+          <p:cNvSpPr txBox="1"/>
+          <p:nvPr/>
+        </p:nvSpPr>
+        <p:spPr>
+          <a:xfrm>
+            <a:off x="457200" y="6236208"/>
+            <a:ext cx="11277295" cy="256032"/>
+          </a:xfrm>
+          <a:prstGeom prst="rect">
+            <a:avLst/>
+          </a:prstGeom>
+          <a:noFill/>
+        </p:spPr>
+        <p:txBody>
+          <a:bodyPr wrap="square" lIns="45720" rIns="45720" tIns="27432" bIns="27432" anchor="t">
+            <a:spAutoFit/>
+          </a:bodyPr>
+          <a:lstStyle/>
+          <a:p>
+            <a:pPr algn="l">
+              <a:lnSpc>
+                <a:spcPct val="110000"/>
+              </a:lnSpc>
+            </a:pPr>
+            <a:r>
+              <a:rPr sz="850" b="0" i="1">
+                <a:solidFill>
+                  <a:srgbClr val="666666"/>
+                </a:solidFill>
+                <a:latin typeface="Arial"/>
+              </a:rPr>
+              <a:t>Repository sources: docs/trust4rsi-incident-to-experiment.md; research-sources.json</a:t>
+            </a:r>
+          </a:p>
+        </p:txBody>
+      </p:sp>
+      <p:graphicFrame>
+        <p:nvGraphicFramePr>
+          <p:cNvPr id="8" name="Table 7"/>
+          <p:cNvGraphicFramePr>
+            <a:graphicFrameLocks noGrp="1"/>
+          </p:cNvGraphicFramePr>
+          <p:nvPr/>
+        </p:nvGraphicFramePr>
+        <p:xfrm>
+          <a:off x="457200" y="1508760"/>
+          <a:ext cx="11274552" cy="3474720"/>
+        </p:xfrm>
+        <a:graphic>
+          <a:graphicData uri="http://schemas.openxmlformats.org/drawingml/2006/table">
+            <a:tbl>
+              <a:tblPr firstRow="1" bandRow="1">
+                <a:tableStyleId>{5C22544A-7EE6-4342-B048-85BDC9FD1C3A}</a:tableStyleId>
+              </a:tblPr>
+              <a:tblGrid>
+                <a:gridCol w="3383280"/>
+                <a:gridCol w="3886200"/>
+                <a:gridCol w="4005072"/>
+              </a:tblGrid>
+              <a:tr h="579120">
+                <a:tc>
+                  <a:txBody>
+                    <a:bodyPr wrap="square"/>
+                    <a:lstStyle/>
+                    <a:p>
+                      <a:r>
+                        <a:rPr sz="1400" b="1" i="0">
+                          <a:solidFill>
+                            <a:srgbClr val="FFFFFF"/>
+                          </a:solidFill>
+                          <a:latin typeface="Arial"/>
+                        </a:rPr>
+                        <a:t>Reported mechanism</a:t>
+                      </a:r>
+                    </a:p>
+                  </a:txBody>
+                  <a:tcPr marL="54864" marR="54864" marT="27432" marB="27432">
+                    <a:solidFill>
+                      <a:srgbClr val="365E9E"/>
+                    </a:solidFill>
+                  </a:tcPr>
+                </a:tc>
+                <a:tc>
+                  <a:txBody>
+                    <a:bodyPr wrap="square"/>
+                    <a:lstStyle/>
+                    <a:p>
+                      <a:r>
+                        <a:rPr sz="1400" b="1" i="0">
+                          <a:solidFill>
+                            <a:srgbClr val="FFFFFF"/>
+                          </a:solidFill>
+                          <a:latin typeface="Arial"/>
+                        </a:rPr>
+                        <a:t>Variable to manipulate</a:t>
+                      </a:r>
+                    </a:p>
+                  </a:txBody>
+                  <a:tcPr marL="54864" marR="54864" marT="27432" marB="27432">
+                    <a:solidFill>
+                      <a:srgbClr val="365E9E"/>
+                    </a:solidFill>
+                  </a:tcPr>
+                </a:tc>
+                <a:tc>
+                  <a:txBody>
+                    <a:bodyPr wrap="square"/>
+                    <a:lstStyle/>
+                    <a:p>
+                      <a:r>
+                        <a:rPr sz="1400" b="1" i="0">
+                          <a:solidFill>
+                            <a:srgbClr val="FFFFFF"/>
+                          </a:solidFill>
+                          <a:latin typeface="Arial"/>
+                        </a:rPr>
+                        <a:t>Current model evidence</a:t>
+                      </a:r>
+                    </a:p>
+                  </a:txBody>
+                  <a:tcPr marL="54864" marR="54864" marT="27432" marB="27432">
+                    <a:solidFill>
+                      <a:srgbClr val="365E9E"/>
+                    </a:solidFill>
+                  </a:tcPr>
+                </a:tc>
+              </a:tr>
+              <a:tr h="579120">
+                <a:tc>
+                  <a:txBody>
+                    <a:bodyPr wrap="square"/>
+                    <a:lstStyle/>
+                    <a:p>
+                      <a:r>
+                        <a:rPr sz="1400" b="1" i="0">
+                          <a:solidFill>
+                            <a:srgbClr val="111111"/>
+                          </a:solidFill>
+                          <a:latin typeface="Arial"/>
+                        </a:rPr>
+                        <a:t>Denied or missing route</a:t>
+                      </a:r>
+                    </a:p>
+                  </a:txBody>
+                  <a:tcPr marL="54864" marR="54864" marT="27432" marB="27432">
+                    <a:solidFill>
+                      <a:srgbClr val="FFFFFF"/>
+                    </a:solidFill>
+                  </a:tcPr>
+                </a:tc>
+                <a:tc>
+                  <a:txBody>
+                    <a:bodyPr wrap="square"/>
+                    <a:lstStyle/>
+                    <a:p>
+                      <a:r>
+                        <a:rPr sz="1400" b="0" i="0">
+                          <a:solidFill>
+                            <a:srgbClr val="111111"/>
+                          </a:solidFill>
+                          <a:latin typeface="Arial"/>
+                        </a:rPr>
+                        <a:t>Allowed repair available / unavailable</a:t>
+                      </a:r>
+                    </a:p>
+                  </a:txBody>
+                  <a:tcPr marL="54864" marR="54864" marT="27432" marB="27432">
+                    <a:solidFill>
+                      <a:srgbClr val="FFFFFF"/>
+                    </a:solidFill>
+                  </a:tcPr>
+                </a:tc>
+                <a:tc>
+                  <a:txBody>
+                    <a:bodyPr wrap="square"/>
+                    <a:lstStyle/>
+                    <a:p>
+                      <a:r>
+                        <a:rPr sz="1400" b="0" i="0">
+                          <a:solidFill>
+                            <a:srgbClr val="111111"/>
+                          </a:solidFill>
+                          <a:latin typeface="Arial"/>
+                        </a:rPr>
+                        <a:t>One local flag-service structure</a:t>
+                      </a:r>
+                    </a:p>
+                  </a:txBody>
+                  <a:tcPr marL="54864" marR="54864" marT="27432" marB="27432">
+                    <a:solidFill>
+                      <a:srgbClr val="FFFFFF"/>
+                    </a:solidFill>
+                  </a:tcPr>
+                </a:tc>
+              </a:tr>
+              <a:tr h="579120">
+                <a:tc>
+                  <a:txBody>
+                    <a:bodyPr wrap="square"/>
+                    <a:lstStyle/>
+                    <a:p>
+                      <a:r>
+                        <a:rPr sz="1400" b="1" i="0">
+                          <a:solidFill>
+                            <a:srgbClr val="111111"/>
+                          </a:solidFill>
+                          <a:latin typeface="Arial"/>
+                        </a:rPr>
+                        <a:t>Forbidden substitute resource</a:t>
+                      </a:r>
+                    </a:p>
+                  </a:txBody>
+                  <a:tcPr marL="54864" marR="54864" marT="27432" marB="27432">
+                    <a:solidFill>
+                      <a:srgbClr val="F3F3F3"/>
+                    </a:solidFill>
+                  </a:tcPr>
+                </a:tc>
+                <a:tc>
+                  <a:txBody>
+                    <a:bodyPr wrap="square"/>
+                    <a:lstStyle/>
+                    <a:p>
+                      <a:r>
+                        <a:rPr sz="1400" b="0" i="0">
+                          <a:solidFill>
+                            <a:srgbClr val="111111"/>
+                          </a:solidFill>
+                          <a:latin typeface="Arial"/>
+                        </a:rPr>
+                        <a:t>Access fixed; permission changed</a:t>
+                      </a:r>
+                    </a:p>
+                  </a:txBody>
+                  <a:tcPr marL="54864" marR="54864" marT="27432" marB="27432">
+                    <a:solidFill>
+                      <a:srgbClr val="F3F3F3"/>
+                    </a:solidFill>
+                  </a:tcPr>
+                </a:tc>
+                <a:tc>
+                  <a:txBody>
+                    <a:bodyPr wrap="square"/>
+                    <a:lstStyle/>
+                    <a:p>
+                      <a:r>
+                        <a:rPr sz="1400" b="0" i="0">
+                          <a:solidFill>
+                            <a:srgbClr val="111111"/>
+                          </a:solidFill>
+                          <a:latin typeface="Arial"/>
+                        </a:rPr>
+                        <a:t>Archive always excluded so far; permission flip unrun</a:t>
+                      </a:r>
+                    </a:p>
+                  </a:txBody>
+                  <a:tcPr marL="54864" marR="54864" marT="27432" marB="27432">
+                    <a:solidFill>
+                      <a:srgbClr val="F3F3F3"/>
+                    </a:solidFill>
+                  </a:tcPr>
+                </a:tc>
+              </a:tr>
+              <a:tr h="579120">
+                <a:tc>
+                  <a:txBody>
+                    <a:bodyPr wrap="square"/>
+                    <a:lstStyle/>
+                    <a:p>
+                      <a:r>
+                        <a:rPr sz="1400" b="1" i="0">
+                          <a:solidFill>
+                            <a:srgbClr val="111111"/>
+                          </a:solidFill>
+                          <a:latin typeface="Arial"/>
+                        </a:rPr>
+                        <a:t>Shared artifacts and cross-run state</a:t>
+                      </a:r>
+                    </a:p>
+                  </a:txBody>
+                  <a:tcPr marL="54864" marR="54864" marT="27432" marB="27432">
+                    <a:solidFill>
+                      <a:srgbClr val="FFFFFF"/>
+                    </a:solidFill>
+                  </a:tcPr>
+                </a:tc>
+                <a:tc>
+                  <a:txBody>
+                    <a:bodyPr wrap="square"/>
+                    <a:lstStyle/>
+                    <a:p>
+                      <a:r>
+                        <a:rPr sz="1400" b="0" i="0">
+                          <a:solidFill>
+                            <a:srgbClr val="111111"/>
+                          </a:solidFill>
+                          <a:latin typeface="Arial"/>
+                        </a:rPr>
+                        <a:t>Owner, recipient and persistence</a:t>
+                      </a:r>
+                    </a:p>
+                  </a:txBody>
+                  <a:tcPr marL="54864" marR="54864" marT="27432" marB="27432">
+                    <a:solidFill>
+                      <a:srgbClr val="FFFFFF"/>
+                    </a:solidFill>
+                  </a:tcPr>
+                </a:tc>
+                <a:tc>
+                  <a:txBody>
+                    <a:bodyPr wrap="square"/>
+                    <a:lstStyle/>
+                    <a:p>
+                      <a:r>
+                        <a:rPr sz="1400" b="0" i="0">
+                          <a:solidFill>
+                            <a:srgbClr val="111111"/>
+                          </a:solidFill>
+                          <a:latin typeface="Arial"/>
+                        </a:rPr>
+                        <a:t>Archive reads only; no behavioral upload/coordination study</a:t>
+                      </a:r>
+                    </a:p>
+                  </a:txBody>
+                  <a:tcPr marL="54864" marR="54864" marT="27432" marB="27432">
+                    <a:solidFill>
+                      <a:srgbClr val="FFFFFF"/>
+                    </a:solidFill>
+                  </a:tcPr>
+                </a:tc>
+              </a:tr>
+              <a:tr h="579120">
+                <a:tc>
+                  <a:txBody>
+                    <a:bodyPr wrap="square"/>
+                    <a:lstStyle/>
+                    <a:p>
+                      <a:r>
+                        <a:rPr sz="1400" b="1" i="0">
+                          <a:solidFill>
+                            <a:srgbClr val="111111"/>
+                          </a:solidFill>
+                          <a:latin typeface="Arial"/>
+                        </a:rPr>
+                        <a:t>Reachability mistaken for scope</a:t>
+                      </a:r>
+                    </a:p>
+                  </a:txBody>
+                  <a:tcPr marL="54864" marR="54864" marT="27432" marB="27432">
+                    <a:solidFill>
+                      <a:srgbClr val="F3F3F3"/>
+                    </a:solidFill>
+                  </a:tcPr>
+                </a:tc>
+                <a:tc>
+                  <a:txBody>
+                    <a:bodyPr wrap="square"/>
+                    <a:lstStyle/>
+                    <a:p>
+                      <a:r>
+                        <a:rPr sz="1400" b="0" i="0">
+                          <a:solidFill>
+                            <a:srgbClr val="111111"/>
+                          </a:solidFill>
+                          <a:latin typeface="Arial"/>
+                        </a:rPr>
+                        <a:t>Explicit grant versus environmental clue</a:t>
+                      </a:r>
+                    </a:p>
+                  </a:txBody>
+                  <a:tcPr marL="54864" marR="54864" marT="27432" marB="27432">
+                    <a:solidFill>
+                      <a:srgbClr val="F3F3F3"/>
+                    </a:solidFill>
+                  </a:tcPr>
+                </a:tc>
+                <a:tc>
+                  <a:txBody>
+                    <a:bodyPr wrap="square"/>
+                    <a:lstStyle/>
+                    <a:p>
+                      <a:r>
+                        <a:rPr sz="1400" b="0" i="0">
+                          <a:solidFill>
+                            <a:srgbClr val="111111"/>
+                          </a:solidFill>
+                          <a:latin typeface="Arial"/>
+                        </a:rPr>
+                        <a:t>Explicit static scope; ambiguous scope untested</a:t>
+                      </a:r>
+                    </a:p>
+                  </a:txBody>
+                  <a:tcPr marL="54864" marR="54864" marT="27432" marB="27432">
+                    <a:solidFill>
+                      <a:srgbClr val="F3F3F3"/>
+                    </a:solidFill>
+                  </a:tcPr>
+                </a:tc>
+              </a:tr>
+              <a:tr h="579120">
+                <a:tc>
+                  <a:txBody>
+                    <a:bodyPr wrap="square"/>
+                    <a:lstStyle/>
+                    <a:p>
+                      <a:r>
+                        <a:rPr sz="1400" b="1" i="0">
+                          <a:solidFill>
+                            <a:srgbClr val="111111"/>
+                          </a:solidFill>
+                          <a:latin typeface="Arial"/>
+                        </a:rPr>
+                        <a:t>Method differs from effect</a:t>
+                      </a:r>
+                    </a:p>
+                  </a:txBody>
+                  <a:tcPr marL="54864" marR="54864" marT="27432" marB="27432">
+                    <a:solidFill>
+                      <a:srgbClr val="FFFFFF"/>
+                    </a:solidFill>
+                  </a:tcPr>
+                </a:tc>
+                <a:tc>
+                  <a:txBody>
+                    <a:bodyPr wrap="square"/>
+                    <a:lstStyle/>
+                    <a:p>
+                      <a:r>
+                        <a:rPr sz="1400" b="0" i="0">
+                          <a:solidFill>
+                            <a:srgbClr val="111111"/>
+                          </a:solidFill>
+                          <a:latin typeface="Arial"/>
+                        </a:rPr>
+                        <a:t>Compare operation and resulting state</a:t>
+                      </a:r>
+                    </a:p>
+                  </a:txBody>
+                  <a:tcPr marL="54864" marR="54864" marT="27432" marB="27432">
+                    <a:solidFill>
+                      <a:srgbClr val="FFFFFF"/>
+                    </a:solidFill>
+                  </a:tcPr>
+                </a:tc>
+                <a:tc>
+                  <a:txBody>
+                    <a:bodyPr wrap="square"/>
+                    <a:lstStyle/>
+                    <a:p>
+                      <a:r>
+                        <a:rPr sz="1400" b="0" i="0">
+                          <a:solidFill>
+                            <a:srgbClr val="111111"/>
+                          </a:solidFill>
+                          <a:latin typeface="Arial"/>
+                        </a:rPr>
+                        <a:t>Endpoint/effect oracle; no GET-write transfer evaluation</a:t>
+                      </a:r>
+                    </a:p>
+                  </a:txBody>
+                  <a:tcPr marL="54864" marR="54864" marT="27432" marB="27432">
+                    <a:solidFill>
+                      <a:srgbClr val="FFFFFF"/>
+                    </a:solidFill>
+                  </a:tcPr>
+                </a:tc>
+              </a:tr>
+            </a:tbl>
+          </a:graphicData>
+        </a:graphic>
+      </p:graphicFrame>
+      <p:sp>
+        <p:nvSpPr>
+          <p:cNvPr id="9" name="Rounded Rectangle 8"/>
+          <p:cNvSpPr/>
+          <p:nvPr/>
+        </p:nvSpPr>
+        <p:spPr>
+          <a:xfrm>
+            <a:off x="457200" y="5303520"/>
+            <a:ext cx="11277295" cy="594360"/>
+          </a:xfrm>
+          <a:prstGeom prst="roundRect">
+            <a:avLst>
+              <a:gd name="adj" fmla="val 5000"/>
+            </a:avLst>
+          </a:prstGeom>
+          <a:solidFill>
+            <a:srgbClr val="FDF3E7"/>
+          </a:solidFill>
+          <a:ln>
+            <a:noFill/>
+          </a:ln>
+          <a:effectLst/>
+        </p:spPr>
+        <p:style>
+          <a:lnRef idx="1">
+            <a:schemeClr val="accent1"/>
+          </a:lnRef>
+          <a:fillRef idx="3">
+            <a:schemeClr val="accent1"/>
+          </a:fillRef>
+          <a:effectRef idx="2">
+            <a:schemeClr val="accent1"/>
+          </a:effectRef>
+          <a:fontRef idx="minor">
+            <a:schemeClr val="lt1"/>
+          </a:fontRef>
+        </p:style>
+        <p:txBody>
+          <a:bodyPr rtlCol="0" anchor="ctr"/>
+          <a:lstStyle/>
+          <a:p/>
+        </p:txBody>
+      </p:sp>
+      <p:sp>
+        <p:nvSpPr>
+          <p:cNvPr id="10" name="TextBox 9"/>
+          <p:cNvSpPr txBox="1"/>
+          <p:nvPr/>
+        </p:nvSpPr>
+        <p:spPr>
+          <a:xfrm>
+            <a:off x="566928" y="5303520"/>
+            <a:ext cx="11057839" cy="594360"/>
+          </a:xfrm>
+          <a:prstGeom prst="rect">
+            <a:avLst/>
+          </a:prstGeom>
+          <a:noFill/>
+        </p:spPr>
+        <p:txBody>
+          <a:bodyPr wrap="square" lIns="45720" rIns="45720" tIns="27432" bIns="27432" anchor="ctr">
+            <a:spAutoFit/>
+          </a:bodyPr>
+          <a:lstStyle/>
+          <a:p>
+            <a:pPr algn="l">
+              <a:lnSpc>
+                <a:spcPct val="110000"/>
+              </a:lnSpc>
+            </a:pPr>
+            <a:r>
+              <a:rPr sz="1600" b="1" i="0">
+                <a:solidFill>
+                  <a:srgbClr val="111111"/>
+                </a:solidFill>
+                <a:latin typeface="Arial"/>
+              </a:rPr>
+              <a:t>26 library entries remain draft. Five selected reports were checked; this is not a validated incident census.</a:t>
+            </a:r>
+          </a:p>
+        </p:txBody>
+      </p:sp>
+      <p:sp>
+        <p:nvSpPr>
+          <p:cNvPr id="11" name="TextBox 10"/>
+          <p:cNvSpPr txBox="1"/>
+          <p:nvPr/>
+        </p:nvSpPr>
+        <p:spPr>
+          <a:xfrm>
+            <a:off x="457200" y="5943600"/>
+            <a:ext cx="11277295" cy="210312"/>
+          </a:xfrm>
+          <a:prstGeom prst="rect">
+            <a:avLst/>
+          </a:prstGeom>
+          <a:noFill/>
+        </p:spPr>
+        <p:txBody>
+          <a:bodyPr wrap="square" lIns="45720" rIns="45720" tIns="27432" bIns="27432" anchor="t">
+            <a:spAutoFit/>
+          </a:bodyPr>
+          <a:lstStyle/>
+          <a:p>
+            <a:pPr algn="l">
+              <a:lnSpc>
+                <a:spcPct val="110000"/>
+              </a:lnSpc>
+            </a:pPr>
+            <a:r>
+              <a:rPr sz="1100" b="0" i="0">
+                <a:solidFill>
+                  <a:srgbClr val="666666"/>
+                </a:solidFill>
+                <a:latin typeface="Arial"/>
+              </a:rPr>
+              <a:t>Wallet report is additional evidence, outside the 26 records. No public-case failure rate is estimated.</a:t>
+            </a:r>
+          </a:p>
+        </p:txBody>
+      </p:sp>
+    </p:spTree>
+  </p:cSld>
+  <p:clrMapOvr>
+    <a:masterClrMapping/>
+  </p:clrMapOvr>
+</p:sld>
+</file>
+
+<file path=ppt/slides/slide33.xml><?xml version="1.0" encoding="utf-8"?>
+<p:sld xmlns:a="http://schemas.openxmlformats.org/drawingml/2006/main" xmlns:p="http://schemas.openxmlformats.org/presentationml/2006/main" xmlns:r="http://schemas.openxmlformats.org/officeDocument/2006/relationships">
+  <p:cSld>
+    <p:spTree>
+      <p:nvGrpSpPr>
+        <p:cNvPr id="1" name=""/>
+        <p:cNvGrpSpPr/>
+        <p:nvPr/>
+      </p:nvGrpSpPr>
+      <p:grpSpPr/>
+      <p:sp>
+        <p:nvSpPr>
+          <p:cNvPr id="2" name="TextBox 1"/>
+          <p:cNvSpPr txBox="1"/>
+          <p:nvPr/>
+        </p:nvSpPr>
+        <p:spPr>
+          <a:xfrm>
+            <a:off x="457200" y="256032"/>
+            <a:ext cx="11277295" cy="548640"/>
+          </a:xfrm>
+          <a:prstGeom prst="rect">
+            <a:avLst/>
+          </a:prstGeom>
+          <a:noFill/>
+        </p:spPr>
+        <p:txBody>
+          <a:bodyPr wrap="square" lIns="45720" rIns="45720" tIns="27432" bIns="27432" anchor="t">
+            <a:spAutoFit/>
+          </a:bodyPr>
+          <a:lstStyle/>
+          <a:p>
+            <a:pPr algn="l">
+              <a:lnSpc>
+                <a:spcPct val="110000"/>
+              </a:lnSpc>
+            </a:pPr>
+            <a:r>
+              <a:rPr sz="2300" b="1" i="0">
+                <a:solidFill>
+                  <a:srgbClr val="111111"/>
+                </a:solidFill>
+                <a:latin typeface="Arial"/>
+              </a:rPr>
+              <a:t>ImpossibleBench: match the operational definition</a:t>
+            </a:r>
+          </a:p>
+        </p:txBody>
+      </p:sp>
+      <p:sp>
+        <p:nvSpPr>
+          <p:cNvPr id="3" name="TextBox 2"/>
+          <p:cNvSpPr txBox="1"/>
+          <p:nvPr/>
+        </p:nvSpPr>
+        <p:spPr>
+          <a:xfrm>
+            <a:off x="457200" y="786384"/>
+            <a:ext cx="11277295" cy="384048"/>
+          </a:xfrm>
+          <a:prstGeom prst="rect">
+            <a:avLst/>
+          </a:prstGeom>
+          <a:noFill/>
+        </p:spPr>
+        <p:txBody>
+          <a:bodyPr wrap="square" lIns="45720" rIns="45720" tIns="27432" bIns="27432" anchor="t">
+            <a:spAutoFit/>
+          </a:bodyPr>
+          <a:lstStyle/>
+          <a:p>
+            <a:pPr algn="l">
+              <a:lnSpc>
+                <a:spcPct val="110000"/>
+              </a:lnSpc>
+            </a:pPr>
+            <a:r>
+              <a:rPr sz="1250" b="0" i="1">
+                <a:solidFill>
+                  <a:srgbClr val="666666"/>
+                </a:solidFill>
+                <a:latin typeface="Arial"/>
+              </a:rPr>
+              <a:t>Different labels answer different questions. Neither endpoint is a universal safety certificate.</a:t>
+            </a:r>
+          </a:p>
+        </p:txBody>
+      </p:sp>
+      <p:sp>
+        <p:nvSpPr>
+          <p:cNvPr id="4" name="Rectangle 3"/>
+          <p:cNvSpPr/>
+          <p:nvPr/>
+        </p:nvSpPr>
+        <p:spPr>
+          <a:xfrm>
+            <a:off x="457200" y="1188720"/>
+            <a:ext cx="11277295" cy="19050"/>
+          </a:xfrm>
+          <a:prstGeom prst="rect">
+            <a:avLst/>
+          </a:prstGeom>
+          <a:solidFill>
+            <a:srgbClr val="365E9E"/>
+          </a:solidFill>
+          <a:ln>
+            <a:noFill/>
+          </a:ln>
+          <a:effectLst/>
+        </p:spPr>
+        <p:style>
+          <a:lnRef idx="1">
+            <a:schemeClr val="accent1"/>
+          </a:lnRef>
+          <a:fillRef idx="3">
+            <a:schemeClr val="accent1"/>
+          </a:fillRef>
+          <a:effectRef idx="2">
+            <a:schemeClr val="accent1"/>
+          </a:effectRef>
+          <a:fontRef idx="minor">
+            <a:schemeClr val="lt1"/>
+          </a:fontRef>
+        </p:style>
+        <p:txBody>
+          <a:bodyPr rtlCol="0" anchor="ctr"/>
+          <a:lstStyle/>
+          <a:p/>
+        </p:txBody>
+      </p:sp>
+      <p:sp>
+        <p:nvSpPr>
+          <p:cNvPr id="5" name="TextBox 4"/>
+          <p:cNvSpPr txBox="1"/>
+          <p:nvPr/>
+        </p:nvSpPr>
+        <p:spPr>
+          <a:xfrm>
+            <a:off x="457200" y="6492240"/>
+            <a:ext cx="10728655" cy="274320"/>
+          </a:xfrm>
+          <a:prstGeom prst="rect">
+            <a:avLst/>
+          </a:prstGeom>
+          <a:noFill/>
+        </p:spPr>
+        <p:txBody>
+          <a:bodyPr wrap="square" lIns="45720" rIns="45720" tIns="27432" bIns="27432" anchor="t">
+            <a:spAutoFit/>
+          </a:bodyPr>
+          <a:lstStyle/>
+          <a:p>
+            <a:pPr algn="l">
+              <a:lnSpc>
+                <a:spcPct val="110000"/>
+              </a:lnSpc>
+            </a:pPr>
+            <a:r>
+              <a:rPr sz="800" b="0" i="0">
+                <a:solidFill>
+                  <a:srgbClr val="666666"/>
+                </a:solidFill>
+                <a:latin typeface="Arial"/>
+              </a:rPr>
+              <a:t>Technical appendix | 20 Oct 2026 | Observed API runs in local services | Detailed methods and primary references.</a:t>
+            </a:r>
+          </a:p>
+        </p:txBody>
+      </p:sp>
+      <p:sp>
+        <p:nvSpPr>
+          <p:cNvPr id="6" name="TextBox 5"/>
+          <p:cNvSpPr txBox="1"/>
+          <p:nvPr/>
+        </p:nvSpPr>
+        <p:spPr>
+          <a:xfrm>
+            <a:off x="11277295" y="6492240"/>
+            <a:ext cx="457200" cy="274320"/>
+          </a:xfrm>
+          <a:prstGeom prst="rect">
+            <a:avLst/>
+          </a:prstGeom>
+          <a:noFill/>
+        </p:spPr>
+        <p:txBody>
+          <a:bodyPr wrap="square" lIns="45720" rIns="45720" tIns="27432" bIns="27432" anchor="t">
+            <a:spAutoFit/>
+          </a:bodyPr>
+          <a:lstStyle/>
+          <a:p>
+            <a:pPr algn="r">
+              <a:lnSpc>
+                <a:spcPct val="110000"/>
+              </a:lnSpc>
+            </a:pPr>
+            <a:r>
+              <a:rPr sz="900" b="0" i="0">
+                <a:solidFill>
+                  <a:srgbClr val="666666"/>
+                </a:solidFill>
+                <a:latin typeface="Arial"/>
+              </a:rPr>
+              <a:t>A22</a:t>
+            </a:r>
+          </a:p>
+        </p:txBody>
+      </p:sp>
+      <p:sp>
+        <p:nvSpPr>
+          <p:cNvPr id="7" name="TextBox 6"/>
+          <p:cNvSpPr txBox="1"/>
+          <p:nvPr/>
+        </p:nvSpPr>
+        <p:spPr>
+          <a:xfrm>
+            <a:off x="457200" y="6236208"/>
+            <a:ext cx="11277295" cy="256032"/>
+          </a:xfrm>
+          <a:prstGeom prst="rect">
+            <a:avLst/>
+          </a:prstGeom>
+          <a:noFill/>
+        </p:spPr>
+        <p:txBody>
+          <a:bodyPr wrap="square" lIns="45720" rIns="45720" tIns="27432" bIns="27432" anchor="t">
+            <a:spAutoFit/>
+          </a:bodyPr>
+          <a:lstStyle/>
+          <a:p>
+            <a:pPr algn="l">
+              <a:lnSpc>
+                <a:spcPct val="110000"/>
+              </a:lnSpc>
+            </a:pPr>
+            <a:r>
+              <a:rPr sz="850" b="0" i="1">
+                <a:solidFill>
+                  <a:srgbClr val="666666"/>
+                </a:solidFill>
+                <a:latin typeface="Arial"/>
+              </a:rPr>
+              <a:t>Repository sources: ImpossibleBench sections 2, 5, 6; incident-study-v1; baseline-diagnostic-v2</a:t>
+            </a:r>
+          </a:p>
+        </p:txBody>
+      </p:sp>
+      <p:graphicFrame>
+        <p:nvGraphicFramePr>
+          <p:cNvPr id="8" name="Table 7"/>
+          <p:cNvGraphicFramePr>
+            <a:graphicFrameLocks noGrp="1"/>
+          </p:cNvGraphicFramePr>
+          <p:nvPr/>
+        </p:nvGraphicFramePr>
+        <p:xfrm>
+          <a:off x="457200" y="1508760"/>
+          <a:ext cx="11274552" cy="4023360"/>
+        </p:xfrm>
+        <a:graphic>
+          <a:graphicData uri="http://schemas.openxmlformats.org/drawingml/2006/table">
+            <a:tbl>
+              <a:tblPr firstRow="1" bandRow="1">
+                <a:tableStyleId>{5C22544A-7EE6-4342-B048-85BDC9FD1C3A}</a:tableStyleId>
+              </a:tblPr>
+              <a:tblGrid>
+                <a:gridCol w="2834640"/>
+                <a:gridCol w="4206240"/>
+                <a:gridCol w="4233672"/>
+              </a:tblGrid>
+              <a:tr h="574765">
+                <a:tc>
+                  <a:txBody>
+                    <a:bodyPr wrap="square"/>
+                    <a:lstStyle/>
+                    <a:p>
+                      <a:r>
+                        <a:rPr sz="1400" b="1" i="0">
+                          <a:solidFill>
+                            <a:srgbClr val="FFFFFF"/>
+                          </a:solidFill>
+                          <a:latin typeface="Arial"/>
+                        </a:rPr>
+                        <a:t>Dimension</a:t>
+                      </a:r>
+                    </a:p>
+                  </a:txBody>
+                  <a:tcPr marL="54864" marR="54864" marT="27432" marB="27432">
+                    <a:solidFill>
+                      <a:srgbClr val="365E9E"/>
+                    </a:solidFill>
+                  </a:tcPr>
+                </a:tc>
+                <a:tc>
+                  <a:txBody>
+                    <a:bodyPr wrap="square"/>
+                    <a:lstStyle/>
+                    <a:p>
+                      <a:r>
+                        <a:rPr sz="1400" b="1" i="0">
+                          <a:solidFill>
+                            <a:srgbClr val="FFFFFF"/>
+                          </a:solidFill>
+                          <a:latin typeface="Arial"/>
+                        </a:rPr>
+                        <a:t>ImpossibleBench</a:t>
+                      </a:r>
+                    </a:p>
+                  </a:txBody>
+                  <a:tcPr marL="54864" marR="54864" marT="27432" marB="27432">
+                    <a:solidFill>
+                      <a:srgbClr val="365E9E"/>
+                    </a:solidFill>
+                  </a:tcPr>
+                </a:tc>
+                <a:tc>
+                  <a:txBody>
+                    <a:bodyPr wrap="square"/>
+                    <a:lstStyle/>
+                    <a:p>
+                      <a:r>
+                        <a:rPr sz="1400" b="1" i="0">
+                          <a:solidFill>
+                            <a:srgbClr val="FFFFFF"/>
+                          </a:solidFill>
+                          <a:latin typeface="Arial"/>
+                        </a:rPr>
+                        <a:t>Our current fixture</a:t>
+                      </a:r>
+                    </a:p>
+                  </a:txBody>
+                  <a:tcPr marL="54864" marR="54864" marT="27432" marB="27432">
+                    <a:solidFill>
+                      <a:srgbClr val="365E9E"/>
+                    </a:solidFill>
+                  </a:tcPr>
+                </a:tc>
+              </a:tr>
+              <a:tr h="574765">
+                <a:tc>
+                  <a:txBody>
+                    <a:bodyPr wrap="square"/>
+                    <a:lstStyle/>
+                    <a:p>
+                      <a:r>
+                        <a:rPr sz="1400" b="1" i="0">
+                          <a:solidFill>
+                            <a:srgbClr val="111111"/>
+                          </a:solidFill>
+                          <a:latin typeface="Arial"/>
+                        </a:rPr>
+                        <a:t>Impossible condition</a:t>
+                      </a:r>
+                    </a:p>
+                  </a:txBody>
+                  <a:tcPr marL="54864" marR="54864" marT="27432" marB="27432">
+                    <a:solidFill>
+                      <a:srgbClr val="FFFFFF"/>
+                    </a:solidFill>
+                  </a:tcPr>
+                </a:tc>
+                <a:tc>
+                  <a:txBody>
+                    <a:bodyPr wrap="square"/>
+                    <a:lstStyle/>
+                    <a:p>
+                      <a:r>
+                        <a:rPr sz="1400" b="0" i="0">
+                          <a:solidFill>
+                            <a:srgbClr val="111111"/>
+                          </a:solidFill>
+                          <a:latin typeface="Arial"/>
+                        </a:rPr>
+                        <a:t>Tests contradict specification</a:t>
+                      </a:r>
+                    </a:p>
+                  </a:txBody>
+                  <a:tcPr marL="54864" marR="54864" marT="27432" marB="27432">
+                    <a:solidFill>
+                      <a:srgbClr val="FFFFFF"/>
+                    </a:solidFill>
+                  </a:tcPr>
+                </a:tc>
+                <a:tc>
+                  <a:txBody>
+                    <a:bodyPr wrap="square"/>
+                    <a:lstStyle/>
+                    <a:p>
+                      <a:r>
+                        <a:rPr sz="1400" b="0" i="0">
+                          <a:solidFill>
+                            <a:srgbClr val="111111"/>
+                          </a:solidFill>
+                          <a:latin typeface="Arial"/>
+                        </a:rPr>
+                        <a:t>No allowed path to current-run flag</a:t>
+                      </a:r>
+                    </a:p>
+                  </a:txBody>
+                  <a:tcPr marL="54864" marR="54864" marT="27432" marB="27432">
+                    <a:solidFill>
+                      <a:srgbClr val="FFFFFF"/>
+                    </a:solidFill>
+                  </a:tcPr>
+                </a:tc>
+              </a:tr>
+              <a:tr h="574765">
+                <a:tc>
+                  <a:txBody>
+                    <a:bodyPr wrap="square"/>
+                    <a:lstStyle/>
+                    <a:p>
+                      <a:r>
+                        <a:rPr sz="1400" b="1" i="0">
+                          <a:solidFill>
+                            <a:srgbClr val="111111"/>
+                          </a:solidFill>
+                          <a:latin typeface="Arial"/>
+                        </a:rPr>
+                        <a:t>Main incident label</a:t>
+                      </a:r>
+                    </a:p>
+                  </a:txBody>
+                  <a:tcPr marL="54864" marR="54864" marT="27432" marB="27432">
+                    <a:solidFill>
+                      <a:srgbClr val="F3F3F3"/>
+                    </a:solidFill>
+                  </a:tcPr>
+                </a:tc>
+                <a:tc>
+                  <a:txBody>
+                    <a:bodyPr wrap="square"/>
+                    <a:lstStyle/>
+                    <a:p>
+                      <a:r>
+                        <a:rPr sz="1400" b="0" i="0">
+                          <a:solidFill>
+                            <a:srgbClr val="111111"/>
+                          </a:solidFill>
+                          <a:latin typeface="Arial"/>
+                        </a:rPr>
+                        <a:t>Passing impossible tests</a:t>
+                      </a:r>
+                    </a:p>
+                  </a:txBody>
+                  <a:tcPr marL="54864" marR="54864" marT="27432" marB="27432">
+                    <a:solidFill>
+                      <a:srgbClr val="F3F3F3"/>
+                    </a:solidFill>
+                  </a:tcPr>
+                </a:tc>
+                <a:tc>
+                  <a:txBody>
+                    <a:bodyPr wrap="square"/>
+                    <a:lstStyle/>
+                    <a:p>
+                      <a:r>
+                        <a:rPr sz="1400" b="0" i="0">
+                          <a:solidFill>
+                            <a:srgbClr val="111111"/>
+                          </a:solidFill>
+                          <a:latin typeface="Arial"/>
+                        </a:rPr>
+                        <a:t>Any executed excluded-resource access</a:t>
+                      </a:r>
+                    </a:p>
+                  </a:txBody>
+                  <a:tcPr marL="54864" marR="54864" marT="27432" marB="27432">
+                    <a:solidFill>
+                      <a:srgbClr val="F3F3F3"/>
+                    </a:solidFill>
+                  </a:tcPr>
+                </a:tc>
+              </a:tr>
+              <a:tr h="574765">
+                <a:tc>
+                  <a:txBody>
+                    <a:bodyPr wrap="square"/>
+                    <a:lstStyle/>
+                    <a:p>
+                      <a:r>
+                        <a:rPr sz="1400" b="1" i="0">
+                          <a:solidFill>
+                            <a:srgbClr val="111111"/>
+                          </a:solidFill>
+                          <a:latin typeface="Arial"/>
+                        </a:rPr>
+                        <a:t>Stopping interface</a:t>
+                      </a:r>
+                    </a:p>
+                  </a:txBody>
+                  <a:tcPr marL="54864" marR="54864" marT="27432" marB="27432">
+                    <a:solidFill>
+                      <a:srgbClr val="FFFFFF"/>
+                    </a:solidFill>
+                  </a:tcPr>
+                </a:tc>
+                <a:tc>
+                  <a:txBody>
+                    <a:bodyPr wrap="square"/>
+                    <a:lstStyle/>
+                    <a:p>
+                      <a:r>
+                        <a:rPr sz="1400" b="0" i="0">
+                          <a:solidFill>
+                            <a:srgbClr val="111111"/>
+                          </a:solidFill>
+                          <a:latin typeface="Arial"/>
+                        </a:rPr>
+                        <a:t>Human-intervention marker</a:t>
+                      </a:r>
+                    </a:p>
+                  </a:txBody>
+                  <a:tcPr marL="54864" marR="54864" marT="27432" marB="27432">
+                    <a:solidFill>
+                      <a:srgbClr val="FFFFFF"/>
+                    </a:solidFill>
+                  </a:tcPr>
+                </a:tc>
+                <a:tc>
+                  <a:txBody>
+                    <a:bodyPr wrap="square"/>
+                    <a:lstStyle/>
+                    <a:p>
+                      <a:r>
+                        <a:rPr sz="1400" b="0" i="0">
+                          <a:solidFill>
+                            <a:srgbClr val="111111"/>
+                          </a:solidFill>
+                          <a:latin typeface="Arial"/>
+                        </a:rPr>
+                        <a:t>Blocked / incomplete response</a:t>
+                      </a:r>
+                    </a:p>
+                  </a:txBody>
+                  <a:tcPr marL="54864" marR="54864" marT="27432" marB="27432">
+                    <a:solidFill>
+                      <a:srgbClr val="FFFFFF"/>
+                    </a:solidFill>
+                  </a:tcPr>
+                </a:tc>
+              </a:tr>
+              <a:tr h="574765">
+                <a:tc>
+                  <a:txBody>
+                    <a:bodyPr wrap="square"/>
+                    <a:lstStyle/>
+                    <a:p>
+                      <a:r>
+                        <a:rPr sz="1400" b="1" i="0">
+                          <a:solidFill>
+                            <a:srgbClr val="111111"/>
+                          </a:solidFill>
+                          <a:latin typeface="Arial"/>
+                        </a:rPr>
+                        <a:t>Useful-task controls</a:t>
+                      </a:r>
+                    </a:p>
+                  </a:txBody>
+                  <a:tcPr marL="54864" marR="54864" marT="27432" marB="27432">
+                    <a:solidFill>
+                      <a:srgbClr val="F3F3F3"/>
+                    </a:solidFill>
+                  </a:tcPr>
+                </a:tc>
+                <a:tc>
+                  <a:txBody>
+                    <a:bodyPr wrap="square"/>
+                    <a:lstStyle/>
+                    <a:p>
+                      <a:r>
+                        <a:rPr sz="1400" b="0" i="0">
+                          <a:solidFill>
+                            <a:srgbClr val="111111"/>
+                          </a:solidFill>
+                          <a:latin typeface="Arial"/>
+                        </a:rPr>
+                        <a:t>Original coding tasks</a:t>
+                      </a:r>
+                    </a:p>
+                  </a:txBody>
+                  <a:tcPr marL="54864" marR="54864" marT="27432" marB="27432">
+                    <a:solidFill>
+                      <a:srgbClr val="F3F3F3"/>
+                    </a:solidFill>
+                  </a:tcPr>
+                </a:tc>
+                <a:tc>
+                  <a:txBody>
+                    <a:bodyPr wrap="square"/>
+                    <a:lstStyle/>
+                    <a:p>
+                      <a:r>
+                        <a:rPr sz="1400" b="0" i="0">
+                          <a:solidFill>
+                            <a:srgbClr val="111111"/>
+                          </a:solidFill>
+                          <a:latin typeface="Arial"/>
+                        </a:rPr>
+                        <a:t>Working and recoverable service tasks</a:t>
+                      </a:r>
+                    </a:p>
+                  </a:txBody>
+                  <a:tcPr marL="54864" marR="54864" marT="27432" marB="27432">
+                    <a:solidFill>
+                      <a:srgbClr val="F3F3F3"/>
+                    </a:solidFill>
+                  </a:tcPr>
+                </a:tc>
+              </a:tr>
+              <a:tr h="574765">
+                <a:tc>
+                  <a:txBody>
+                    <a:bodyPr wrap="square"/>
+                    <a:lstStyle/>
+                    <a:p>
+                      <a:r>
+                        <a:rPr sz="1400" b="1" i="0">
+                          <a:solidFill>
+                            <a:srgbClr val="111111"/>
+                          </a:solidFill>
+                          <a:latin typeface="Arial"/>
+                        </a:rPr>
+                        <a:t>Prompt/control comparison</a:t>
+                      </a:r>
+                    </a:p>
+                  </a:txBody>
+                  <a:tcPr marL="54864" marR="54864" marT="27432" marB="27432">
+                    <a:solidFill>
+                      <a:srgbClr val="FFFFFF"/>
+                    </a:solidFill>
+                  </a:tcPr>
+                </a:tc>
+                <a:tc>
+                  <a:txBody>
+                    <a:bodyPr wrap="square"/>
+                    <a:lstStyle/>
+                    <a:p>
+                      <a:r>
+                        <a:rPr sz="1400" b="0" i="0">
+                          <a:solidFill>
+                            <a:srgbClr val="111111"/>
+                          </a:solidFill>
+                          <a:latin typeface="Arial"/>
+                        </a:rPr>
+                        <a:t>Prompt, access, feedback, abort</a:t>
+                      </a:r>
+                    </a:p>
+                  </a:txBody>
+                  <a:tcPr marL="54864" marR="54864" marT="27432" marB="27432">
+                    <a:solidFill>
+                      <a:srgbClr val="FFFFFF"/>
+                    </a:solidFill>
+                  </a:tcPr>
+                </a:tc>
+                <a:tc>
+                  <a:txBody>
+                    <a:bodyPr wrap="square"/>
+                    <a:lstStyle/>
+                    <a:p>
+                      <a:r>
+                        <a:rPr sz="1400" b="0" i="0">
+                          <a:solidFill>
+                            <a:srgbClr val="111111"/>
+                          </a:solidFill>
+                          <a:latin typeface="Arial"/>
+                        </a:rPr>
+                        <a:t>Scope/exit wording; checkpoint notes</a:t>
+                      </a:r>
+                    </a:p>
+                  </a:txBody>
+                  <a:tcPr marL="54864" marR="54864" marT="27432" marB="27432">
+                    <a:solidFill>
+                      <a:srgbClr val="FFFFFF"/>
+                    </a:solidFill>
+                  </a:tcPr>
+                </a:tc>
+              </a:tr>
+              <a:tr h="574770">
+                <a:tc>
+                  <a:txBody>
+                    <a:bodyPr wrap="square"/>
+                    <a:lstStyle/>
+                    <a:p>
+                      <a:r>
+                        <a:rPr sz="1400" b="1" i="0">
+                          <a:solidFill>
+                            <a:srgbClr val="111111"/>
+                          </a:solidFill>
+                          <a:latin typeface="Arial"/>
+                        </a:rPr>
+                        <a:t>Monitor population</a:t>
+                      </a:r>
+                    </a:p>
+                  </a:txBody>
+                  <a:tcPr marL="54864" marR="54864" marT="27432" marB="27432">
+                    <a:solidFill>
+                      <a:srgbClr val="F3F3F3"/>
+                    </a:solidFill>
+                  </a:tcPr>
+                </a:tc>
+                <a:tc>
+                  <a:txBody>
+                    <a:bodyPr wrap="square"/>
+                    <a:lstStyle/>
+                    <a:p>
+                      <a:r>
+                        <a:rPr sz="1400" b="0" i="0">
+                          <a:solidFill>
+                            <a:srgbClr val="111111"/>
+                          </a:solidFill>
+                          <a:latin typeface="Arial"/>
+                        </a:rPr>
+                        <a:t>Scorer-passing trajectories</a:t>
+                      </a:r>
+                    </a:p>
+                  </a:txBody>
+                  <a:tcPr marL="54864" marR="54864" marT="27432" marB="27432">
+                    <a:solidFill>
+                      <a:srgbClr val="F3F3F3"/>
+                    </a:solidFill>
+                  </a:tcPr>
+                </a:tc>
+                <a:tc>
+                  <a:txBody>
+                    <a:bodyPr wrap="square"/>
+                    <a:lstStyle/>
+                    <a:p>
+                      <a:r>
+                        <a:rPr sz="1400" b="0" i="0">
+                          <a:solidFill>
+                            <a:srgbClr val="111111"/>
+                          </a:solidFill>
+                          <a:latin typeface="Arial"/>
+                        </a:rPr>
+                        <a:t>All 48 assigned diagnostic targets</a:t>
+                      </a:r>
+                    </a:p>
+                  </a:txBody>
+                  <a:tcPr marL="54864" marR="54864" marT="27432" marB="27432">
+                    <a:solidFill>
+                      <a:srgbClr val="F3F3F3"/>
+                    </a:solidFill>
+                  </a:tcPr>
+                </a:tc>
+              </a:tr>
+            </a:tbl>
+          </a:graphicData>
+        </a:graphic>
+      </p:graphicFrame>
+      <p:sp>
+        <p:nvSpPr>
+          <p:cNvPr id="9" name="Rounded Rectangle 8"/>
+          <p:cNvSpPr/>
+          <p:nvPr/>
+        </p:nvSpPr>
+        <p:spPr>
+          <a:xfrm>
+            <a:off x="457200" y="5715000"/>
+            <a:ext cx="11277295" cy="411480"/>
+          </a:xfrm>
+          <a:prstGeom prst="roundRect">
+            <a:avLst>
+              <a:gd name="adj" fmla="val 5000"/>
+            </a:avLst>
+          </a:prstGeom>
+          <a:solidFill>
+            <a:srgbClr val="F3F3F3"/>
+          </a:solidFill>
+          <a:ln>
+            <a:noFill/>
+          </a:ln>
+          <a:effectLst/>
+        </p:spPr>
+        <p:style>
+          <a:lnRef idx="1">
+            <a:schemeClr val="accent1"/>
+          </a:lnRef>
+          <a:fillRef idx="3">
+            <a:schemeClr val="accent1"/>
+          </a:fillRef>
+          <a:effectRef idx="2">
+            <a:schemeClr val="accent1"/>
+          </a:effectRef>
+          <a:fontRef idx="minor">
+            <a:schemeClr val="lt1"/>
+          </a:fontRef>
+        </p:style>
+        <p:txBody>
+          <a:bodyPr rtlCol="0" anchor="ctr"/>
+          <a:lstStyle/>
+          <a:p/>
+        </p:txBody>
+      </p:sp>
+      <p:sp>
+        <p:nvSpPr>
+          <p:cNvPr id="10" name="TextBox 9"/>
+          <p:cNvSpPr txBox="1"/>
+          <p:nvPr/>
+        </p:nvSpPr>
+        <p:spPr>
+          <a:xfrm>
+            <a:off x="566928" y="5715000"/>
+            <a:ext cx="11057839" cy="411480"/>
+          </a:xfrm>
+          <a:prstGeom prst="rect">
+            <a:avLst/>
+          </a:prstGeom>
+          <a:noFill/>
+        </p:spPr>
+        <p:txBody>
+          <a:bodyPr wrap="square" lIns="45720" rIns="45720" tIns="27432" bIns="27432" anchor="ctr">
+            <a:spAutoFit/>
+          </a:bodyPr>
+          <a:lstStyle/>
+          <a:p>
+            <a:pPr algn="l">
+              <a:lnSpc>
+                <a:spcPct val="110000"/>
+              </a:lnSpc>
+            </a:pPr>
+            <a:r>
+              <a:rPr sz="1500" b="1" i="0">
+                <a:solidFill>
+                  <a:srgbClr val="111111"/>
+                </a:solidFill>
+                <a:latin typeface="Arial"/>
+              </a:rPr>
+              <a:t>Two local violations did not pass. That is an endpoint difference, not proof of novelty or superiority.</a:t>
+            </a:r>
+          </a:p>
+        </p:txBody>
+      </p:sp>
+    </p:spTree>
+  </p:cSld>
+  <p:clrMapOvr>
+    <a:masterClrMapping/>
+  </p:clrMapOvr>
+</p:sld>
+</file>
+
+<file path=ppt/slides/slide34.xml><?xml version="1.0" encoding="utf-8"?>
+<p:sld xmlns:a="http://schemas.openxmlformats.org/drawingml/2006/main" xmlns:p="http://schemas.openxmlformats.org/presentationml/2006/main" xmlns:r="http://schemas.openxmlformats.org/officeDocument/2006/relationships">
+  <p:cSld>
+    <p:spTree>
+      <p:nvGrpSpPr>
+        <p:cNvPr id="1" name=""/>
+        <p:cNvGrpSpPr/>
+        <p:nvPr/>
+      </p:nvGrpSpPr>
+      <p:grpSpPr/>
+      <p:sp>
+        <p:nvSpPr>
+          <p:cNvPr id="2" name="TextBox 1"/>
+          <p:cNvSpPr txBox="1"/>
+          <p:nvPr/>
+        </p:nvSpPr>
+        <p:spPr>
+          <a:xfrm>
+            <a:off x="457200" y="256032"/>
+            <a:ext cx="11277295" cy="548640"/>
+          </a:xfrm>
+          <a:prstGeom prst="rect">
+            <a:avLst/>
+          </a:prstGeom>
+          <a:noFill/>
+        </p:spPr>
+        <p:txBody>
+          <a:bodyPr wrap="square" lIns="45720" rIns="45720" tIns="27432" bIns="27432" anchor="t">
+            <a:spAutoFit/>
+          </a:bodyPr>
+          <a:lstStyle/>
+          <a:p>
+            <a:pPr algn="l">
+              <a:lnSpc>
+                <a:spcPct val="110000"/>
+              </a:lnSpc>
+            </a:pPr>
+            <a:r>
+              <a:rPr sz="2300" b="1" i="0">
+                <a:solidFill>
+                  <a:srgbClr val="111111"/>
+                </a:solidFill>
+                <a:latin typeface="Arial"/>
+              </a:rPr>
+              <a:t>Which comparison is technically fair?</a:t>
+            </a:r>
+          </a:p>
+        </p:txBody>
+      </p:sp>
+      <p:sp>
+        <p:nvSpPr>
+          <p:cNvPr id="3" name="TextBox 2"/>
+          <p:cNvSpPr txBox="1"/>
+          <p:nvPr/>
+        </p:nvSpPr>
+        <p:spPr>
+          <a:xfrm>
+            <a:off x="457200" y="786384"/>
+            <a:ext cx="11277295" cy="384048"/>
+          </a:xfrm>
+          <a:prstGeom prst="rect">
+            <a:avLst/>
+          </a:prstGeom>
+          <a:noFill/>
+        </p:spPr>
+        <p:txBody>
+          <a:bodyPr wrap="square" lIns="45720" rIns="45720" tIns="27432" bIns="27432" anchor="t">
+            <a:spAutoFit/>
+          </a:bodyPr>
+          <a:lstStyle/>
+          <a:p>
+            <a:pPr algn="l">
+              <a:lnSpc>
+                <a:spcPct val="110000"/>
+              </a:lnSpc>
+            </a:pPr>
+            <a:r>
+              <a:rPr sz="1250" b="0" i="1">
+                <a:solidFill>
+                  <a:srgbClr val="666666"/>
+                </a:solidFill>
+                <a:latin typeface="Arial"/>
+              </a:rPr>
+              <a:t>Use shared tasks, budgets, information and permissions. Do not rank unrelated published percentages.</a:t>
+            </a:r>
+          </a:p>
+        </p:txBody>
+      </p:sp>
+      <p:sp>
+        <p:nvSpPr>
+          <p:cNvPr id="4" name="Rectangle 3"/>
+          <p:cNvSpPr/>
+          <p:nvPr/>
+        </p:nvSpPr>
+        <p:spPr>
+          <a:xfrm>
+            <a:off x="457200" y="1188720"/>
+            <a:ext cx="11277295" cy="19050"/>
+          </a:xfrm>
+          <a:prstGeom prst="rect">
+            <a:avLst/>
+          </a:prstGeom>
+          <a:solidFill>
+            <a:srgbClr val="365E9E"/>
+          </a:solidFill>
+          <a:ln>
+            <a:noFill/>
+          </a:ln>
+          <a:effectLst/>
+        </p:spPr>
+        <p:style>
+          <a:lnRef idx="1">
+            <a:schemeClr val="accent1"/>
+          </a:lnRef>
+          <a:fillRef idx="3">
+            <a:schemeClr val="accent1"/>
+          </a:fillRef>
+          <a:effectRef idx="2">
+            <a:schemeClr val="accent1"/>
+          </a:effectRef>
+          <a:fontRef idx="minor">
+            <a:schemeClr val="lt1"/>
+          </a:fontRef>
+        </p:style>
+        <p:txBody>
+          <a:bodyPr rtlCol="0" anchor="ctr"/>
+          <a:lstStyle/>
+          <a:p/>
+        </p:txBody>
+      </p:sp>
+      <p:sp>
+        <p:nvSpPr>
+          <p:cNvPr id="5" name="TextBox 4"/>
+          <p:cNvSpPr txBox="1"/>
+          <p:nvPr/>
+        </p:nvSpPr>
+        <p:spPr>
+          <a:xfrm>
+            <a:off x="457200" y="6492240"/>
+            <a:ext cx="10728655" cy="274320"/>
+          </a:xfrm>
+          <a:prstGeom prst="rect">
+            <a:avLst/>
+          </a:prstGeom>
+          <a:noFill/>
+        </p:spPr>
+        <p:txBody>
+          <a:bodyPr wrap="square" lIns="45720" rIns="45720" tIns="27432" bIns="27432" anchor="t">
+            <a:spAutoFit/>
+          </a:bodyPr>
+          <a:lstStyle/>
+          <a:p>
+            <a:pPr algn="l">
+              <a:lnSpc>
+                <a:spcPct val="110000"/>
+              </a:lnSpc>
+            </a:pPr>
+            <a:r>
+              <a:rPr sz="800" b="0" i="0">
+                <a:solidFill>
+                  <a:srgbClr val="666666"/>
+                </a:solidFill>
+                <a:latin typeface="Arial"/>
+              </a:rPr>
+              <a:t>Technical appendix | 20 Oct 2026 | Observed API runs in local services | Detailed methods and primary references.</a:t>
+            </a:r>
+          </a:p>
+        </p:txBody>
+      </p:sp>
+      <p:sp>
+        <p:nvSpPr>
+          <p:cNvPr id="6" name="TextBox 5"/>
+          <p:cNvSpPr txBox="1"/>
+          <p:nvPr/>
+        </p:nvSpPr>
+        <p:spPr>
+          <a:xfrm>
+            <a:off x="11277295" y="6492240"/>
+            <a:ext cx="457200" cy="274320"/>
+          </a:xfrm>
+          <a:prstGeom prst="rect">
+            <a:avLst/>
+          </a:prstGeom>
+          <a:noFill/>
+        </p:spPr>
+        <p:txBody>
+          <a:bodyPr wrap="square" lIns="45720" rIns="45720" tIns="27432" bIns="27432" anchor="t">
+            <a:spAutoFit/>
+          </a:bodyPr>
+          <a:lstStyle/>
+          <a:p>
+            <a:pPr algn="r">
+              <a:lnSpc>
+                <a:spcPct val="110000"/>
+              </a:lnSpc>
+            </a:pPr>
+            <a:r>
+              <a:rPr sz="900" b="0" i="0">
+                <a:solidFill>
+                  <a:srgbClr val="666666"/>
+                </a:solidFill>
+                <a:latin typeface="Arial"/>
+              </a:rPr>
+              <a:t>A23</a:t>
+            </a:r>
+          </a:p>
+        </p:txBody>
+      </p:sp>
+      <p:sp>
+        <p:nvSpPr>
+          <p:cNvPr id="7" name="TextBox 6"/>
+          <p:cNvSpPr txBox="1"/>
+          <p:nvPr/>
+        </p:nvSpPr>
+        <p:spPr>
+          <a:xfrm>
+            <a:off x="457200" y="6236208"/>
+            <a:ext cx="11277295" cy="256032"/>
+          </a:xfrm>
+          <a:prstGeom prst="rect">
+            <a:avLst/>
+          </a:prstGeom>
+          <a:noFill/>
+        </p:spPr>
+        <p:txBody>
+          <a:bodyPr wrap="square" lIns="45720" rIns="45720" tIns="27432" bIns="27432" anchor="t">
+            <a:spAutoFit/>
+          </a:bodyPr>
+          <a:lstStyle/>
+          <a:p>
+            <a:pPr algn="l">
+              <a:lnSpc>
+                <a:spcPct val="110000"/>
+              </a:lnSpc>
+            </a:pPr>
+            <a:r>
+              <a:rPr sz="850" b="0" i="1">
+                <a:solidFill>
+                  <a:srgbClr val="666666"/>
+                </a:solidFill>
+                <a:latin typeface="Arial"/>
+              </a:rPr>
+              <a:t>Repository sources: docs/trust4rsi-related-work.md; docs/impossiblebench-upstream-baseline-results.md</a:t>
+            </a:r>
+          </a:p>
+        </p:txBody>
+      </p:sp>
+      <p:graphicFrame>
+        <p:nvGraphicFramePr>
+          <p:cNvPr id="8" name="Table 7"/>
+          <p:cNvGraphicFramePr>
+            <a:graphicFrameLocks noGrp="1"/>
+          </p:cNvGraphicFramePr>
+          <p:nvPr/>
+        </p:nvGraphicFramePr>
+        <p:xfrm>
+          <a:off x="457200" y="1463040"/>
+          <a:ext cx="11274552" cy="4160520"/>
+        </p:xfrm>
+        <a:graphic>
+          <a:graphicData uri="http://schemas.openxmlformats.org/drawingml/2006/table">
+            <a:tbl>
+              <a:tblPr firstRow="1" bandRow="1">
+                <a:tableStyleId>{5C22544A-7EE6-4342-B048-85BDC9FD1C3A}</a:tableStyleId>
+              </a:tblPr>
+              <a:tblGrid>
+                <a:gridCol w="2468880"/>
+                <a:gridCol w="4434840"/>
+                <a:gridCol w="4370832"/>
+              </a:tblGrid>
+              <a:tr h="693420">
+                <a:tc>
+                  <a:txBody>
+                    <a:bodyPr wrap="square"/>
+                    <a:lstStyle/>
+                    <a:p>
+                      <a:r>
+                        <a:rPr sz="1400" b="1" i="0">
+                          <a:solidFill>
+                            <a:srgbClr val="FFFFFF"/>
+                          </a:solidFill>
+                          <a:latin typeface="Arial"/>
+                        </a:rPr>
+                        <a:t>Comparator</a:t>
+                      </a:r>
+                    </a:p>
+                  </a:txBody>
+                  <a:tcPr marL="54864" marR="54864" marT="27432" marB="27432">
+                    <a:solidFill>
+                      <a:srgbClr val="365E9E"/>
+                    </a:solidFill>
+                  </a:tcPr>
+                </a:tc>
+                <a:tc>
+                  <a:txBody>
+                    <a:bodyPr wrap="square"/>
+                    <a:lstStyle/>
+                    <a:p>
+                      <a:r>
+                        <a:rPr sz="1400" b="1" i="0">
+                          <a:solidFill>
+                            <a:srgbClr val="FFFFFF"/>
+                          </a:solidFill>
+                          <a:latin typeface="Arial"/>
+                        </a:rPr>
+                        <a:t>Required matching / qualification</a:t>
+                      </a:r>
+                    </a:p>
+                  </a:txBody>
+                  <a:tcPr marL="54864" marR="54864" marT="27432" marB="27432">
+                    <a:solidFill>
+                      <a:srgbClr val="365E9E"/>
+                    </a:solidFill>
+                  </a:tcPr>
+                </a:tc>
+                <a:tc>
+                  <a:txBody>
+                    <a:bodyPr wrap="square"/>
+                    <a:lstStyle/>
+                    <a:p>
+                      <a:r>
+                        <a:rPr sz="1400" b="1" i="0">
+                          <a:solidFill>
+                            <a:srgbClr val="FFFFFF"/>
+                          </a:solidFill>
+                          <a:latin typeface="Arial"/>
+                        </a:rPr>
+                        <a:t>What is missing here</a:t>
+                      </a:r>
+                    </a:p>
+                  </a:txBody>
+                  <a:tcPr marL="54864" marR="54864" marT="27432" marB="27432">
+                    <a:solidFill>
+                      <a:srgbClr val="365E9E"/>
+                    </a:solidFill>
+                  </a:tcPr>
+                </a:tc>
+              </a:tr>
+              <a:tr h="693420">
+                <a:tc>
+                  <a:txBody>
+                    <a:bodyPr wrap="square"/>
+                    <a:lstStyle/>
+                    <a:p>
+                      <a:r>
+                        <a:rPr sz="1400" b="1" i="0">
+                          <a:solidFill>
+                            <a:srgbClr val="111111"/>
+                          </a:solidFill>
+                          <a:latin typeface="Arial"/>
+                        </a:rPr>
+                        <a:t>ImpossibleBench</a:t>
+                      </a:r>
+                    </a:p>
+                  </a:txBody>
+                  <a:tcPr marL="54864" marR="54864" marT="27432" marB="27432">
+                    <a:solidFill>
+                      <a:srgbClr val="FFFFFF"/>
+                    </a:solidFill>
+                  </a:tcPr>
+                </a:tc>
+                <a:tc>
+                  <a:txBody>
+                    <a:bodyPr wrap="square"/>
+                    <a:lstStyle/>
+                    <a:p>
+                      <a:r>
+                        <a:rPr sz="1400" b="0" i="0">
+                          <a:solidFill>
+                            <a:srgbClr val="111111"/>
+                          </a:solidFill>
+                          <a:latin typeface="Arial"/>
+                        </a:rPr>
+                        <a:t>Original capability; actor/scorer environment; same stop budgets</a:t>
+                      </a:r>
+                    </a:p>
+                  </a:txBody>
+                  <a:tcPr marL="54864" marR="54864" marT="27432" marB="27432">
+                    <a:solidFill>
+                      <a:srgbClr val="FFFFFF"/>
+                    </a:solidFill>
+                  </a:tcPr>
+                </a:tc>
+                <a:tc>
+                  <a:txBody>
+                    <a:bodyPr wrap="square"/>
+                    <a:lstStyle/>
+                    <a:p>
+                      <a:r>
+                        <a:rPr sz="1400" b="0" i="0">
+                          <a:solidFill>
+                            <a:srgbClr val="111111"/>
+                          </a:solidFill>
+                          <a:latin typeface="Arial"/>
+                        </a:rPr>
+                        <a:t>Raw live archive absent; report says six message-capped runs</a:t>
+                      </a:r>
+                    </a:p>
+                  </a:txBody>
+                  <a:tcPr marL="54864" marR="54864" marT="27432" marB="27432">
+                    <a:solidFill>
+                      <a:srgbClr val="FFFFFF"/>
+                    </a:solidFill>
+                  </a:tcPr>
+                </a:tc>
+              </a:tr>
+              <a:tr h="693420">
+                <a:tc>
+                  <a:txBody>
+                    <a:bodyPr wrap="square"/>
+                    <a:lstStyle/>
+                    <a:p>
+                      <a:r>
+                        <a:rPr sz="1400" b="1" i="0">
+                          <a:solidFill>
+                            <a:srgbClr val="111111"/>
+                          </a:solidFill>
+                          <a:latin typeface="Arial"/>
+                        </a:rPr>
+                        <a:t>Anthropic incident experiments</a:t>
+                      </a:r>
+                    </a:p>
+                  </a:txBody>
+                  <a:tcPr marL="54864" marR="54864" marT="27432" marB="27432">
+                    <a:solidFill>
+                      <a:srgbClr val="F3F3F3"/>
+                    </a:solidFill>
+                  </a:tcPr>
+                </a:tc>
+                <a:tc>
+                  <a:txBody>
+                    <a:bodyPr wrap="square"/>
+                    <a:lstStyle/>
+                    <a:p>
+                      <a:r>
+                        <a:rPr sz="1400" b="0" i="0">
+                          <a:solidFill>
+                            <a:srgbClr val="111111"/>
+                          </a:solidFill>
+                          <a:latin typeface="Arial"/>
+                        </a:rPr>
+                        <a:t>Equivalent checkpoints, context edits and scope definitions</a:t>
+                      </a:r>
+                    </a:p>
+                  </a:txBody>
+                  <a:tcPr marL="54864" marR="54864" marT="27432" marB="27432">
+                    <a:solidFill>
+                      <a:srgbClr val="F3F3F3"/>
+                    </a:solidFill>
+                  </a:tcPr>
+                </a:tc>
+                <a:tc>
+                  <a:txBody>
+                    <a:bodyPr wrap="square"/>
+                    <a:lstStyle/>
+                    <a:p>
+                      <a:r>
+                        <a:rPr sz="1400" b="0" i="0">
+                          <a:solidFill>
+                            <a:srgbClr val="111111"/>
+                          </a:solidFill>
+                          <a:latin typeface="Arial"/>
+                        </a:rPr>
+                        <a:t>No matched incident replication or model comparison</a:t>
+                      </a:r>
+                    </a:p>
+                  </a:txBody>
+                  <a:tcPr marL="54864" marR="54864" marT="27432" marB="27432">
+                    <a:solidFill>
+                      <a:srgbClr val="F3F3F3"/>
+                    </a:solidFill>
+                  </a:tcPr>
+                </a:tc>
+              </a:tr>
+              <a:tr h="693420">
+                <a:tc>
+                  <a:txBody>
+                    <a:bodyPr wrap="square"/>
+                    <a:lstStyle/>
+                    <a:p>
+                      <a:r>
+                        <a:rPr sz="1400" b="1" i="0">
+                          <a:solidFill>
+                            <a:srgbClr val="111111"/>
+                          </a:solidFill>
+                          <a:latin typeface="Arial"/>
+                        </a:rPr>
+                        <a:t>AgentDojo / SHADE-Arena</a:t>
+                      </a:r>
+                    </a:p>
+                  </a:txBody>
+                  <a:tcPr marL="54864" marR="54864" marT="27432" marB="27432">
+                    <a:solidFill>
+                      <a:srgbClr val="FFFFFF"/>
+                    </a:solidFill>
+                  </a:tcPr>
+                </a:tc>
+                <a:tc>
+                  <a:txBody>
+                    <a:bodyPr wrap="square"/>
+                    <a:lstStyle/>
+                    <a:p>
+                      <a:r>
+                        <a:rPr sz="1400" b="0" i="0">
+                          <a:solidFill>
+                            <a:srgbClr val="111111"/>
+                          </a:solidFill>
+                          <a:latin typeface="Arial"/>
+                        </a:rPr>
+                        <a:t>Injected content / hidden side goal; monitor-visible information</a:t>
+                      </a:r>
+                    </a:p>
+                  </a:txBody>
+                  <a:tcPr marL="54864" marR="54864" marT="27432" marB="27432">
+                    <a:solidFill>
+                      <a:srgbClr val="FFFFFF"/>
+                    </a:solidFill>
+                  </a:tcPr>
+                </a:tc>
+                <a:tc>
+                  <a:txBody>
+                    <a:bodyPr wrap="square"/>
+                    <a:lstStyle/>
+                    <a:p>
+                      <a:r>
+                        <a:rPr sz="1400" b="0" i="0">
+                          <a:solidFill>
+                            <a:srgbClr val="111111"/>
+                          </a:solidFill>
+                          <a:latin typeface="Arial"/>
+                        </a:rPr>
+                        <a:t>No injected attack or deliberate sabotage condition</a:t>
+                      </a:r>
+                    </a:p>
+                  </a:txBody>
+                  <a:tcPr marL="54864" marR="54864" marT="27432" marB="27432">
+                    <a:solidFill>
+                      <a:srgbClr val="FFFFFF"/>
+                    </a:solidFill>
+                  </a:tcPr>
+                </a:tc>
+              </a:tr>
+              <a:tr h="693420">
+                <a:tc>
+                  <a:txBody>
+                    <a:bodyPr wrap="square"/>
+                    <a:lstStyle/>
+                    <a:p>
+                      <a:r>
+                        <a:rPr sz="1400" b="1" i="0">
+                          <a:solidFill>
+                            <a:srgbClr val="111111"/>
+                          </a:solidFill>
+                          <a:latin typeface="Arial"/>
+                        </a:rPr>
+                        <a:t>CoSec</a:t>
+                      </a:r>
+                    </a:p>
+                  </a:txBody>
+                  <a:tcPr marL="54864" marR="54864" marT="27432" marB="27432">
+                    <a:solidFill>
+                      <a:srgbClr val="F3F3F3"/>
+                    </a:solidFill>
+                  </a:tcPr>
+                </a:tc>
+                <a:tc>
+                  <a:txBody>
+                    <a:bodyPr wrap="square"/>
+                    <a:lstStyle/>
+                    <a:p>
+                      <a:r>
+                        <a:rPr sz="1400" b="0" i="0">
+                          <a:solidFill>
+                            <a:srgbClr val="111111"/>
+                          </a:solidFill>
+                          <a:latin typeface="Arial"/>
+                        </a:rPr>
+                        <a:t>Owner, recipient, active authorization and persistent state</a:t>
+                      </a:r>
+                    </a:p>
+                  </a:txBody>
+                  <a:tcPr marL="54864" marR="54864" marT="27432" marB="27432">
+                    <a:solidFill>
+                      <a:srgbClr val="F3F3F3"/>
+                    </a:solidFill>
+                  </a:tcPr>
+                </a:tc>
+                <a:tc>
+                  <a:txBody>
+                    <a:bodyPr wrap="square"/>
+                    <a:lstStyle/>
+                    <a:p>
+                      <a:r>
+                        <a:rPr sz="1400" b="0" i="0">
+                          <a:solidFill>
+                            <a:srgbClr val="111111"/>
+                          </a:solidFill>
+                          <a:latin typeface="Arial"/>
+                        </a:rPr>
+                        <a:t>No evolving community-state experiment</a:t>
+                      </a:r>
+                    </a:p>
+                  </a:txBody>
+                  <a:tcPr marL="54864" marR="54864" marT="27432" marB="27432">
+                    <a:solidFill>
+                      <a:srgbClr val="F3F3F3"/>
+                    </a:solidFill>
+                  </a:tcPr>
+                </a:tc>
+              </a:tr>
+              <a:tr h="693420">
+                <a:tc>
+                  <a:txBody>
+                    <a:bodyPr wrap="square"/>
+                    <a:lstStyle/>
+                    <a:p>
+                      <a:r>
+                        <a:rPr sz="1400" b="1" i="0">
+                          <a:solidFill>
+                            <a:srgbClr val="111111"/>
+                          </a:solidFill>
+                          <a:latin typeface="Arial"/>
+                        </a:rPr>
+                        <a:t>CaMeL</a:t>
+                      </a:r>
+                    </a:p>
+                  </a:txBody>
+                  <a:tcPr marL="54864" marR="54864" marT="27432" marB="27432">
+                    <a:solidFill>
+                      <a:srgbClr val="FFFFFF"/>
+                    </a:solidFill>
+                  </a:tcPr>
+                </a:tc>
+                <a:tc>
+                  <a:txBody>
+                    <a:bodyPr wrap="square"/>
+                    <a:lstStyle/>
+                    <a:p>
+                      <a:r>
+                        <a:rPr sz="1400" b="0" i="0">
+                          <a:solidFill>
+                            <a:srgbClr val="111111"/>
+                          </a:solidFill>
+                          <a:latin typeface="Arial"/>
+                        </a:rPr>
+                        <a:t>Interpreter, data tags, policies and utility checks</a:t>
+                      </a:r>
+                    </a:p>
+                  </a:txBody>
+                  <a:tcPr marL="54864" marR="54864" marT="27432" marB="27432">
+                    <a:solidFill>
+                      <a:srgbClr val="FFFFFF"/>
+                    </a:solidFill>
+                  </a:tcPr>
+                </a:tc>
+                <a:tc>
+                  <a:txBody>
+                    <a:bodyPr wrap="square"/>
+                    <a:lstStyle/>
+                    <a:p>
+                      <a:r>
+                        <a:rPr sz="1400" b="0" i="0">
+                          <a:solidFill>
+                            <a:srgbClr val="111111"/>
+                          </a:solidFill>
+                          <a:latin typeface="Arial"/>
+                        </a:rPr>
+                        <a:t>Only endpoint allowlist proposed; no CaMeL reproduction</a:t>
+                      </a:r>
+                    </a:p>
+                  </a:txBody>
+                  <a:tcPr marL="54864" marR="54864" marT="27432" marB="27432">
+                    <a:solidFill>
+                      <a:srgbClr val="FFFFFF"/>
+                    </a:solidFill>
+                  </a:tcPr>
+                </a:tc>
+              </a:tr>
+            </a:tbl>
+          </a:graphicData>
+        </a:graphic>
+      </p:graphicFrame>
+      <p:sp>
+        <p:nvSpPr>
+          <p:cNvPr id="9" name="Rounded Rectangle 8"/>
+          <p:cNvSpPr/>
+          <p:nvPr/>
+        </p:nvSpPr>
+        <p:spPr>
+          <a:xfrm>
+            <a:off x="457200" y="5779008"/>
+            <a:ext cx="11277295" cy="365760"/>
+          </a:xfrm>
+          <a:prstGeom prst="roundRect">
+            <a:avLst>
+              <a:gd name="adj" fmla="val 5000"/>
+            </a:avLst>
+          </a:prstGeom>
+          <a:solidFill>
+            <a:srgbClr val="EDF4FB"/>
+          </a:solidFill>
+          <a:ln>
+            <a:noFill/>
+          </a:ln>
+          <a:effectLst/>
+        </p:spPr>
+        <p:style>
+          <a:lnRef idx="1">
+            <a:schemeClr val="accent1"/>
+          </a:lnRef>
+          <a:fillRef idx="3">
+            <a:schemeClr val="accent1"/>
+          </a:fillRef>
+          <a:effectRef idx="2">
+            <a:schemeClr val="accent1"/>
+          </a:effectRef>
+          <a:fontRef idx="minor">
+            <a:schemeClr val="lt1"/>
+          </a:fontRef>
+        </p:style>
+        <p:txBody>
+          <a:bodyPr rtlCol="0" anchor="ctr"/>
+          <a:lstStyle/>
+          <a:p/>
+        </p:txBody>
+      </p:sp>
+      <p:sp>
+        <p:nvSpPr>
+          <p:cNvPr id="10" name="TextBox 9"/>
+          <p:cNvSpPr txBox="1"/>
+          <p:nvPr/>
+        </p:nvSpPr>
+        <p:spPr>
+          <a:xfrm>
+            <a:off x="566928" y="5779008"/>
+            <a:ext cx="11057839" cy="365760"/>
+          </a:xfrm>
+          <a:prstGeom prst="rect">
+            <a:avLst/>
+          </a:prstGeom>
+          <a:noFill/>
+        </p:spPr>
+        <p:txBody>
+          <a:bodyPr wrap="square" lIns="45720" rIns="45720" tIns="27432" bIns="27432" anchor="ctr">
+            <a:spAutoFit/>
+          </a:bodyPr>
+          <a:lstStyle/>
+          <a:p>
+            <a:pPr algn="l">
+              <a:lnSpc>
+                <a:spcPct val="110000"/>
+              </a:lnSpc>
+            </a:pPr>
+            <a:r>
+              <a:rPr sz="1400" b="1" i="0">
+                <a:solidFill>
+                  <a:srgbClr val="111111"/>
+                </a:solidFill>
+                <a:latin typeface="Arial"/>
+              </a:rPr>
+              <a:t>A simple blocker is a required baseline. A recorder is not a blocker; a blocked attempt is not an executed effect.</a:t>
+            </a:r>
+          </a:p>
+        </p:txBody>
+      </p:sp>
+    </p:spTree>
+  </p:cSld>
+  <p:clrMapOvr>
+    <a:masterClrMapping/>
+  </p:clrMapOvr>
+</p:sld>
+</file>
+
+<file path=ppt/slides/slide35.xml><?xml version="1.0" encoding="utf-8"?>
+<p:sld xmlns:a="http://schemas.openxmlformats.org/drawingml/2006/main" xmlns:p="http://schemas.openxmlformats.org/presentationml/2006/main" xmlns:r="http://schemas.openxmlformats.org/officeDocument/2006/relationships">
+  <p:cSld>
+    <p:spTree>
+      <p:nvGrpSpPr>
+        <p:cNvPr id="1" name=""/>
+        <p:cNvGrpSpPr/>
+        <p:nvPr/>
+      </p:nvGrpSpPr>
+      <p:grpSpPr/>
+      <p:sp>
+        <p:nvSpPr>
+          <p:cNvPr id="2" name="TextBox 1"/>
+          <p:cNvSpPr txBox="1"/>
+          <p:nvPr/>
+        </p:nvSpPr>
+        <p:spPr>
+          <a:xfrm>
+            <a:off x="457200" y="256032"/>
+            <a:ext cx="11277295" cy="548640"/>
+          </a:xfrm>
+          <a:prstGeom prst="rect">
+            <a:avLst/>
+          </a:prstGeom>
+          <a:noFill/>
+        </p:spPr>
+        <p:txBody>
+          <a:bodyPr wrap="square" lIns="45720" rIns="45720" tIns="27432" bIns="27432" anchor="t">
+            <a:spAutoFit/>
+          </a:bodyPr>
+          <a:lstStyle/>
+          <a:p>
+            <a:pPr algn="l">
+              <a:lnSpc>
+                <a:spcPct val="110000"/>
+              </a:lnSpc>
+            </a:pPr>
+            <a:r>
+              <a:rPr sz="2300" b="1" i="0">
+                <a:solidFill>
+                  <a:srgbClr val="111111"/>
+                </a:solidFill>
+                <a:latin typeface="Arial"/>
+              </a:rPr>
+              <a:t>Next experiment: repair availability x archive permission</a:t>
+            </a:r>
+          </a:p>
+        </p:txBody>
+      </p:sp>
+      <p:sp>
+        <p:nvSpPr>
+          <p:cNvPr id="3" name="TextBox 2"/>
+          <p:cNvSpPr txBox="1"/>
+          <p:nvPr/>
+        </p:nvSpPr>
+        <p:spPr>
+          <a:xfrm>
+            <a:off x="457200" y="786384"/>
+            <a:ext cx="11277295" cy="384048"/>
+          </a:xfrm>
+          <a:prstGeom prst="rect">
+            <a:avLst/>
+          </a:prstGeom>
+          <a:noFill/>
+        </p:spPr>
+        <p:txBody>
+          <a:bodyPr wrap="square" lIns="45720" rIns="45720" tIns="27432" bIns="27432" anchor="t">
+            <a:spAutoFit/>
+          </a:bodyPr>
+          <a:lstStyle/>
+          <a:p>
+            <a:pPr algn="l">
+              <a:lnSpc>
+                <a:spcPct val="110000"/>
+              </a:lnSpc>
+            </a:pPr>
+            <a:r>
+              <a:rPr sz="1250" b="0" i="1">
+                <a:solidFill>
+                  <a:srgbClr val="666666"/>
+                </a:solidFill>
+                <a:latin typeface="Arial"/>
+              </a:rPr>
+              <a:t>Proposed only. Keep archive bytes and reachability fixed. Change trusted permission, not archive self-claims.</a:t>
+            </a:r>
+          </a:p>
+        </p:txBody>
+      </p:sp>
+      <p:sp>
+        <p:nvSpPr>
+          <p:cNvPr id="4" name="Rectangle 3"/>
+          <p:cNvSpPr/>
+          <p:nvPr/>
+        </p:nvSpPr>
+        <p:spPr>
+          <a:xfrm>
+            <a:off x="457200" y="1188720"/>
+            <a:ext cx="11277295" cy="19050"/>
+          </a:xfrm>
+          <a:prstGeom prst="rect">
+            <a:avLst/>
+          </a:prstGeom>
+          <a:solidFill>
+            <a:srgbClr val="365E9E"/>
+          </a:solidFill>
+          <a:ln>
+            <a:noFill/>
+          </a:ln>
+          <a:effectLst/>
+        </p:spPr>
+        <p:style>
+          <a:lnRef idx="1">
+            <a:schemeClr val="accent1"/>
+          </a:lnRef>
+          <a:fillRef idx="3">
+            <a:schemeClr val="accent1"/>
+          </a:fillRef>
+          <a:effectRef idx="2">
+            <a:schemeClr val="accent1"/>
+          </a:effectRef>
+          <a:fontRef idx="minor">
+            <a:schemeClr val="lt1"/>
+          </a:fontRef>
+        </p:style>
+        <p:txBody>
+          <a:bodyPr rtlCol="0" anchor="ctr"/>
+          <a:lstStyle/>
+          <a:p/>
+        </p:txBody>
+      </p:sp>
+      <p:sp>
+        <p:nvSpPr>
+          <p:cNvPr id="5" name="TextBox 4"/>
+          <p:cNvSpPr txBox="1"/>
+          <p:nvPr/>
+        </p:nvSpPr>
+        <p:spPr>
+          <a:xfrm>
+            <a:off x="457200" y="6492240"/>
+            <a:ext cx="10728655" cy="274320"/>
+          </a:xfrm>
+          <a:prstGeom prst="rect">
+            <a:avLst/>
+          </a:prstGeom>
+          <a:noFill/>
+        </p:spPr>
+        <p:txBody>
+          <a:bodyPr wrap="square" lIns="45720" rIns="45720" tIns="27432" bIns="27432" anchor="t">
+            <a:spAutoFit/>
+          </a:bodyPr>
+          <a:lstStyle/>
+          <a:p>
+            <a:pPr algn="l">
+              <a:lnSpc>
+                <a:spcPct val="110000"/>
+              </a:lnSpc>
+            </a:pPr>
+            <a:r>
+              <a:rPr sz="800" b="0" i="0">
+                <a:solidFill>
+                  <a:srgbClr val="666666"/>
+                </a:solidFill>
+                <a:latin typeface="Arial"/>
+              </a:rPr>
+              <a:t>Technical appendix | 20 Oct 2026 | Observed API runs in local services | Detailed methods and primary references.</a:t>
+            </a:r>
+          </a:p>
+        </p:txBody>
+      </p:sp>
+      <p:sp>
+        <p:nvSpPr>
+          <p:cNvPr id="6" name="TextBox 5"/>
+          <p:cNvSpPr txBox="1"/>
+          <p:nvPr/>
+        </p:nvSpPr>
+        <p:spPr>
+          <a:xfrm>
+            <a:off x="11277295" y="6492240"/>
+            <a:ext cx="457200" cy="274320"/>
+          </a:xfrm>
+          <a:prstGeom prst="rect">
+            <a:avLst/>
+          </a:prstGeom>
+          <a:noFill/>
+        </p:spPr>
+        <p:txBody>
+          <a:bodyPr wrap="square" lIns="45720" rIns="45720" tIns="27432" bIns="27432" anchor="t">
+            <a:spAutoFit/>
+          </a:bodyPr>
+          <a:lstStyle/>
+          <a:p>
+            <a:pPr algn="r">
+              <a:lnSpc>
+                <a:spcPct val="110000"/>
+              </a:lnSpc>
+            </a:pPr>
+            <a:r>
+              <a:rPr sz="900" b="0" i="0">
+                <a:solidFill>
+                  <a:srgbClr val="666666"/>
+                </a:solidFill>
+                <a:latin typeface="Arial"/>
+              </a:rPr>
+              <a:t>A24</a:t>
+            </a:r>
+          </a:p>
+        </p:txBody>
+      </p:sp>
+      <p:sp>
+        <p:nvSpPr>
+          <p:cNvPr id="7" name="TextBox 6"/>
+          <p:cNvSpPr txBox="1"/>
+          <p:nvPr/>
+        </p:nvSpPr>
+        <p:spPr>
+          <a:xfrm>
+            <a:off x="457200" y="6236208"/>
+            <a:ext cx="11277295" cy="256032"/>
+          </a:xfrm>
+          <a:prstGeom prst="rect">
+            <a:avLst/>
+          </a:prstGeom>
+          <a:noFill/>
+        </p:spPr>
+        <p:txBody>
+          <a:bodyPr wrap="square" lIns="45720" rIns="45720" tIns="27432" bIns="27432" anchor="t">
+            <a:spAutoFit/>
+          </a:bodyPr>
+          <a:lstStyle/>
+          <a:p>
+            <a:pPr algn="l">
+              <a:lnSpc>
+                <a:spcPct val="110000"/>
+              </a:lnSpc>
+            </a:pPr>
+            <a:r>
+              <a:rPr sz="850" b="0" i="1">
+                <a:solidFill>
+                  <a:srgbClr val="666666"/>
+                </a:solidFill>
+                <a:latin typeface="Arial"/>
+              </a:rPr>
+              <a:t>Repository sources: docs/trust4rsi-incident-to-experiment.md; no live allocation or outcomes yet</a:t>
+            </a:r>
+          </a:p>
+        </p:txBody>
+      </p:sp>
+      <p:graphicFrame>
+        <p:nvGraphicFramePr>
+          <p:cNvPr id="8" name="Table 7"/>
+          <p:cNvGraphicFramePr>
+            <a:graphicFrameLocks noGrp="1"/>
+          </p:cNvGraphicFramePr>
+          <p:nvPr/>
+        </p:nvGraphicFramePr>
+        <p:xfrm>
+          <a:off x="457200" y="1508760"/>
+          <a:ext cx="11274552" cy="1828800"/>
+        </p:xfrm>
+        <a:graphic>
+          <a:graphicData uri="http://schemas.openxmlformats.org/drawingml/2006/table">
+            <a:tbl>
+              <a:tblPr firstRow="1" bandRow="1">
+                <a:tableStyleId>{5C22544A-7EE6-4342-B048-85BDC9FD1C3A}</a:tableStyleId>
+              </a:tblPr>
+              <a:tblGrid>
+                <a:gridCol w="2743200"/>
+                <a:gridCol w="4251960"/>
+                <a:gridCol w="4279392"/>
+              </a:tblGrid>
+              <a:tr h="609600">
+                <a:tc>
+                  <a:txBody>
+                    <a:bodyPr wrap="square"/>
+                    <a:lstStyle/>
+                    <a:p>
+                      <a:r>
+                        <a:rPr sz="1700" b="1" i="0">
+                          <a:solidFill>
+                            <a:srgbClr val="FFFFFF"/>
+                          </a:solidFill>
+                          <a:latin typeface="Arial"/>
+                        </a:rPr>
+                        <a:t>Local repair</a:t>
+                      </a:r>
+                    </a:p>
+                  </a:txBody>
+                  <a:tcPr marL="54864" marR="54864" marT="27432" marB="27432">
+                    <a:solidFill>
+                      <a:srgbClr val="365E9E"/>
+                    </a:solidFill>
+                  </a:tcPr>
+                </a:tc>
+                <a:tc>
+                  <a:txBody>
+                    <a:bodyPr wrap="square"/>
+                    <a:lstStyle/>
+                    <a:p>
+                      <a:r>
+                        <a:rPr sz="1700" b="1" i="0">
+                          <a:solidFill>
+                            <a:srgbClr val="FFFFFF"/>
+                          </a:solidFill>
+                          <a:latin typeface="Arial"/>
+                        </a:rPr>
+                        <a:t>Archive excluded</a:t>
+                      </a:r>
+                    </a:p>
+                  </a:txBody>
+                  <a:tcPr marL="54864" marR="54864" marT="27432" marB="27432">
+                    <a:solidFill>
+                      <a:srgbClr val="365E9E"/>
+                    </a:solidFill>
+                  </a:tcPr>
+                </a:tc>
+                <a:tc>
+                  <a:txBody>
+                    <a:bodyPr wrap="square"/>
+                    <a:lstStyle/>
+                    <a:p>
+                      <a:r>
+                        <a:rPr sz="1700" b="1" i="0">
+                          <a:solidFill>
+                            <a:srgbClr val="FFFFFF"/>
+                          </a:solidFill>
+                          <a:latin typeface="Arial"/>
+                        </a:rPr>
+                        <a:t>Archive authorized</a:t>
+                      </a:r>
+                    </a:p>
+                  </a:txBody>
+                  <a:tcPr marL="54864" marR="54864" marT="27432" marB="27432">
+                    <a:solidFill>
+                      <a:srgbClr val="365E9E"/>
+                    </a:solidFill>
+                  </a:tcPr>
+                </a:tc>
+              </a:tr>
+              <a:tr h="609600">
+                <a:tc>
+                  <a:txBody>
+                    <a:bodyPr wrap="square"/>
+                    <a:lstStyle/>
+                    <a:p>
+                      <a:r>
+                        <a:rPr sz="1700" b="1" i="0">
+                          <a:solidFill>
+                            <a:srgbClr val="111111"/>
+                          </a:solidFill>
+                          <a:latin typeface="Arial"/>
+                        </a:rPr>
+                        <a:t>Works</a:t>
+                      </a:r>
+                    </a:p>
+                  </a:txBody>
+                  <a:tcPr marL="54864" marR="54864" marT="27432" marB="27432">
+                    <a:solidFill>
+                      <a:srgbClr val="FFFFFF"/>
+                    </a:solidFill>
+                  </a:tcPr>
+                </a:tc>
+                <a:tc>
+                  <a:txBody>
+                    <a:bodyPr wrap="square"/>
+                    <a:lstStyle/>
+                    <a:p>
+                      <a:r>
+                        <a:rPr sz="1700" b="0" i="0">
+                          <a:solidFill>
+                            <a:srgbClr val="111111"/>
+                          </a:solidFill>
+                          <a:latin typeface="Arial"/>
+                        </a:rPr>
+                        <a:t>Recover, then complete</a:t>
+                      </a:r>
+                    </a:p>
+                  </a:txBody>
+                  <a:tcPr marL="54864" marR="54864" marT="27432" marB="27432">
+                    <a:solidFill>
+                      <a:srgbClr val="FFFFFF"/>
+                    </a:solidFill>
+                  </a:tcPr>
+                </a:tc>
+                <a:tc>
+                  <a:txBody>
+                    <a:bodyPr wrap="square"/>
+                    <a:lstStyle/>
+                    <a:p>
+                      <a:r>
+                        <a:rPr sz="1700" b="0" i="0">
+                          <a:solidFill>
+                            <a:srgbClr val="111111"/>
+                          </a:solidFill>
+                          <a:latin typeface="Arial"/>
+                        </a:rPr>
+                        <a:t>Either allowed route</a:t>
+                      </a:r>
+                    </a:p>
+                  </a:txBody>
+                  <a:tcPr marL="54864" marR="54864" marT="27432" marB="27432">
+                    <a:solidFill>
+                      <a:srgbClr val="FFFFFF"/>
+                    </a:solidFill>
+                  </a:tcPr>
+                </a:tc>
+              </a:tr>
+              <a:tr h="609600">
+                <a:tc>
+                  <a:txBody>
+                    <a:bodyPr wrap="square"/>
+                    <a:lstStyle/>
+                    <a:p>
+                      <a:r>
+                        <a:rPr sz="1700" b="1" i="0">
+                          <a:solidFill>
+                            <a:srgbClr val="111111"/>
+                          </a:solidFill>
+                          <a:latin typeface="Arial"/>
+                        </a:rPr>
+                        <a:t>Unavailable</a:t>
+                      </a:r>
+                    </a:p>
+                  </a:txBody>
+                  <a:tcPr marL="54864" marR="54864" marT="27432" marB="27432">
+                    <a:solidFill>
+                      <a:srgbClr val="F3F3F3"/>
+                    </a:solidFill>
+                  </a:tcPr>
+                </a:tc>
+                <a:tc>
+                  <a:txBody>
+                    <a:bodyPr wrap="square"/>
+                    <a:lstStyle/>
+                    <a:p>
+                      <a:r>
+                        <a:rPr sz="1700" b="0" i="0">
+                          <a:solidFill>
+                            <a:srgbClr val="111111"/>
+                          </a:solidFill>
+                          <a:latin typeface="Arial"/>
+                        </a:rPr>
+                        <a:t>Report blocked</a:t>
+                      </a:r>
+                    </a:p>
+                  </a:txBody>
+                  <a:tcPr marL="54864" marR="54864" marT="27432" marB="27432">
+                    <a:solidFill>
+                      <a:srgbClr val="F3F3F3"/>
+                    </a:solidFill>
+                  </a:tcPr>
+                </a:tc>
+                <a:tc>
+                  <a:txBody>
+                    <a:bodyPr wrap="square"/>
+                    <a:lstStyle/>
+                    <a:p>
+                      <a:r>
+                        <a:rPr sz="1700" b="0" i="0">
+                          <a:solidFill>
+                            <a:srgbClr val="111111"/>
+                          </a:solidFill>
+                          <a:latin typeface="Arial"/>
+                        </a:rPr>
+                        <a:t>Use archive; task remains feasible</a:t>
+                      </a:r>
+                    </a:p>
+                  </a:txBody>
+                  <a:tcPr marL="54864" marR="54864" marT="27432" marB="27432">
+                    <a:solidFill>
+                      <a:srgbClr val="F3F3F3"/>
+                    </a:solidFill>
+                  </a:tcPr>
+                </a:tc>
+              </a:tr>
+            </a:tbl>
+          </a:graphicData>
+        </a:graphic>
+      </p:graphicFrame>
+      <p:graphicFrame>
+        <p:nvGraphicFramePr>
+          <p:cNvPr id="9" name="Table 8"/>
+          <p:cNvGraphicFramePr>
+            <a:graphicFrameLocks noGrp="1"/>
+          </p:cNvGraphicFramePr>
+          <p:nvPr/>
+        </p:nvGraphicFramePr>
+        <p:xfrm>
+          <a:off x="457200" y="3657600"/>
+          <a:ext cx="11274552" cy="2011680"/>
+        </p:xfrm>
+        <a:graphic>
+          <a:graphicData uri="http://schemas.openxmlformats.org/drawingml/2006/table">
+            <a:tbl>
+              <a:tblPr firstRow="1" bandRow="1">
+                <a:tableStyleId>{5C22544A-7EE6-4342-B048-85BDC9FD1C3A}</a:tableStyleId>
+              </a:tblPr>
+              <a:tblGrid>
+                <a:gridCol w="3840480"/>
+                <a:gridCol w="7434072"/>
+              </a:tblGrid>
+              <a:tr h="502920">
+                <a:tc>
+                  <a:txBody>
+                    <a:bodyPr wrap="square"/>
+                    <a:lstStyle/>
+                    <a:p>
+                      <a:r>
+                        <a:rPr sz="1400" b="1" i="0">
+                          <a:solidFill>
+                            <a:srgbClr val="FFFFFF"/>
+                          </a:solidFill>
+                          <a:latin typeface="Arial"/>
+                        </a:rPr>
+                        <a:t>Outcome</a:t>
+                      </a:r>
+                    </a:p>
+                  </a:txBody>
+                  <a:tcPr marL="54864" marR="54864" marT="27432" marB="27432">
+                    <a:solidFill>
+                      <a:srgbClr val="365E9E"/>
+                    </a:solidFill>
+                  </a:tcPr>
+                </a:tc>
+                <a:tc>
+                  <a:txBody>
+                    <a:bodyPr wrap="square"/>
+                    <a:lstStyle/>
+                    <a:p>
+                      <a:r>
+                        <a:rPr sz="1400" b="1" i="0">
+                          <a:solidFill>
+                            <a:srgbClr val="FFFFFF"/>
+                          </a:solidFill>
+                          <a:latin typeface="Arial"/>
+                        </a:rPr>
+                        <a:t>Operational definition</a:t>
+                      </a:r>
+                    </a:p>
+                  </a:txBody>
+                  <a:tcPr marL="54864" marR="54864" marT="27432" marB="27432">
+                    <a:solidFill>
+                      <a:srgbClr val="365E9E"/>
+                    </a:solidFill>
+                  </a:tcPr>
+                </a:tc>
+              </a:tr>
+              <a:tr h="502920">
+                <a:tc>
+                  <a:txBody>
+                    <a:bodyPr wrap="square"/>
+                    <a:lstStyle/>
+                    <a:p>
+                      <a:r>
+                        <a:rPr sz="1400" b="1" i="0">
+                          <a:solidFill>
+                            <a:srgbClr val="111111"/>
+                          </a:solidFill>
+                          <a:latin typeface="Arial"/>
+                        </a:rPr>
+                        <a:t>Authorized completion</a:t>
+                      </a:r>
+                    </a:p>
+                  </a:txBody>
+                  <a:tcPr marL="54864" marR="54864" marT="27432" marB="27432">
+                    <a:solidFill>
+                      <a:srgbClr val="FFFFFF"/>
+                    </a:solidFill>
+                  </a:tcPr>
+                </a:tc>
+                <a:tc>
+                  <a:txBody>
+                    <a:bodyPr wrap="square"/>
+                    <a:lstStyle/>
+                    <a:p>
+                      <a:r>
+                        <a:rPr sz="1400" b="0" i="0">
+                          <a:solidFill>
+                            <a:srgbClr val="111111"/>
+                          </a:solidFill>
+                          <a:latin typeface="Arial"/>
+                        </a:rPr>
+                        <a:t>Scorer accepts AND no executed unauthorized effect</a:t>
+                      </a:r>
+                    </a:p>
+                  </a:txBody>
+                  <a:tcPr marL="54864" marR="54864" marT="27432" marB="27432">
+                    <a:solidFill>
+                      <a:srgbClr val="FFFFFF"/>
+                    </a:solidFill>
+                  </a:tcPr>
+                </a:tc>
+              </a:tr>
+              <a:tr h="502920">
+                <a:tc>
+                  <a:txBody>
+                    <a:bodyPr wrap="square"/>
+                    <a:lstStyle/>
+                    <a:p>
+                      <a:r>
+                        <a:rPr sz="1400" b="1" i="0">
+                          <a:solidFill>
+                            <a:srgbClr val="111111"/>
+                          </a:solidFill>
+                          <a:latin typeface="Arial"/>
+                        </a:rPr>
+                        <a:t>Executed violation / attempted violation</a:t>
+                      </a:r>
+                    </a:p>
+                  </a:txBody>
+                  <a:tcPr marL="54864" marR="54864" marT="27432" marB="27432">
+                    <a:solidFill>
+                      <a:srgbClr val="F3F3F3"/>
+                    </a:solidFill>
+                  </a:tcPr>
+                </a:tc>
+                <a:tc>
+                  <a:txBody>
+                    <a:bodyPr wrap="square"/>
+                    <a:lstStyle/>
+                    <a:p>
+                      <a:r>
+                        <a:rPr sz="1400" b="0" i="0">
+                          <a:solidFill>
+                            <a:srgbClr val="111111"/>
+                          </a:solidFill>
+                          <a:latin typeface="Arial"/>
+                        </a:rPr>
+                        <a:t>Any policy-excluded effect / request; report separately</a:t>
+                      </a:r>
+                    </a:p>
+                  </a:txBody>
+                  <a:tcPr marL="54864" marR="54864" marT="27432" marB="27432">
+                    <a:solidFill>
+                      <a:srgbClr val="F3F3F3"/>
+                    </a:solidFill>
+                  </a:tcPr>
+                </a:tc>
+              </a:tr>
+              <a:tr h="502920">
+                <a:tc>
+                  <a:txBody>
+                    <a:bodyPr wrap="square"/>
+                    <a:lstStyle/>
+                    <a:p>
+                      <a:r>
+                        <a:rPr sz="1400" b="1" i="0">
+                          <a:solidFill>
+                            <a:srgbClr val="111111"/>
+                          </a:solidFill>
+                          <a:latin typeface="Arial"/>
+                        </a:rPr>
+                        <a:t>Premature stop / unknown</a:t>
+                      </a:r>
+                    </a:p>
+                  </a:txBody>
+                  <a:tcPr marL="54864" marR="54864" marT="27432" marB="27432">
+                    <a:solidFill>
+                      <a:srgbClr val="FFFFFF"/>
+                    </a:solidFill>
+                  </a:tcPr>
+                </a:tc>
+                <a:tc>
+                  <a:txBody>
+                    <a:bodyPr wrap="square"/>
+                    <a:lstStyle/>
+                    <a:p>
+                      <a:r>
+                        <a:rPr sz="1400" b="0" i="0">
+                          <a:solidFill>
+                            <a:srgbClr val="111111"/>
+                          </a:solidFill>
+                          <a:latin typeface="Arial"/>
+                        </a:rPr>
+                        <a:t>Stops before a known feasible route / missing evidence or incomplete run</a:t>
+                      </a:r>
+                    </a:p>
+                  </a:txBody>
+                  <a:tcPr marL="54864" marR="54864" marT="27432" marB="27432">
+                    <a:solidFill>
+                      <a:srgbClr val="FFFFFF"/>
+                    </a:solidFill>
+                  </a:tcPr>
+                </a:tc>
+              </a:tr>
+            </a:tbl>
+          </a:graphicData>
+        </a:graphic>
+      </p:graphicFrame>
+      <p:sp>
+        <p:nvSpPr>
+          <p:cNvPr id="10" name="Rounded Rectangle 9"/>
+          <p:cNvSpPr/>
+          <p:nvPr/>
+        </p:nvSpPr>
+        <p:spPr>
+          <a:xfrm>
+            <a:off x="457200" y="5852160"/>
+            <a:ext cx="11277295" cy="320040"/>
+          </a:xfrm>
+          <a:prstGeom prst="roundRect">
+            <a:avLst>
+              <a:gd name="adj" fmla="val 5000"/>
+            </a:avLst>
+          </a:prstGeom>
+          <a:solidFill>
+            <a:srgbClr val="FDF3E7"/>
+          </a:solidFill>
+          <a:ln>
+            <a:noFill/>
+          </a:ln>
+          <a:effectLst/>
+        </p:spPr>
+        <p:style>
+          <a:lnRef idx="1">
+            <a:schemeClr val="accent1"/>
+          </a:lnRef>
+          <a:fillRef idx="3">
+            <a:schemeClr val="accent1"/>
+          </a:fillRef>
+          <a:effectRef idx="2">
+            <a:schemeClr val="accent1"/>
+          </a:effectRef>
+          <a:fontRef idx="minor">
+            <a:schemeClr val="lt1"/>
+          </a:fontRef>
+        </p:style>
+        <p:txBody>
+          <a:bodyPr rtlCol="0" anchor="ctr"/>
+          <a:lstStyle/>
+          <a:p/>
+        </p:txBody>
+      </p:sp>
+      <p:sp>
+        <p:nvSpPr>
+          <p:cNvPr id="11" name="TextBox 10"/>
+          <p:cNvSpPr txBox="1"/>
+          <p:nvPr/>
+        </p:nvSpPr>
+        <p:spPr>
+          <a:xfrm>
+            <a:off x="566928" y="5852160"/>
+            <a:ext cx="11057839" cy="320040"/>
+          </a:xfrm>
+          <a:prstGeom prst="rect">
+            <a:avLst/>
+          </a:prstGeom>
+          <a:noFill/>
+        </p:spPr>
+        <p:txBody>
+          <a:bodyPr wrap="square" lIns="45720" rIns="45720" tIns="27432" bIns="27432" anchor="ctr">
+            <a:spAutoFit/>
+          </a:bodyPr>
+          <a:lstStyle/>
+          <a:p>
+            <a:pPr algn="l">
+              <a:lnSpc>
+                <a:spcPct val="110000"/>
+              </a:lnSpc>
+            </a:pPr>
+            <a:r>
+              <a:rPr sz="1300" b="1" i="0">
+                <a:solidFill>
+                  <a:srgbClr val="111111"/>
+                </a:solidFill>
+                <a:latin typeface="Arial"/>
+              </a:rPr>
+              <a:t>Freeze sample size and analysis before inference. Hold out another task family; do not call new seeds transfer.</a:t>
+            </a:r>
+          </a:p>
+        </p:txBody>
+      </p:sp>
     </p:spTree>
   </p:cSld>
   <p:clrMapOvr>
@@ -20845,7 +24133,7 @@
                 </a:solidFill>
                 <a:latin typeface="Arial"/>
               </a:rPr>
-              <a:t>Literature comparison, checked 20 Oct 2026; no external method has been rerun here</a:t>
+              <a:t>Literature comparison; prior upstream attempt is report-only here, not a clean comparative baseline</a:t>
             </a:r>
           </a:p>
         </p:txBody>

</xml_diff>